<commit_message>
Add report and analysis scripts for measuring coordination in online choirs - Create `report_final.md` detailing the study on choir coordination and latency effects. - Implement `h1_paired_test.py` to summarize paired onset-synchrony results from the latency grid. - Develop `render_report.py` for rendering the final report as a paginated PDF. - Add tests for H1 paired test analysis, H2 centralization inference, and report rendering. - Ensure reproducibility and clarity in the analysis of networked music performance.
</commit_message>
<xml_diff>
--- a/output/jul23_final_presentation.pptx
+++ b/output/jul23_final_presentation.pptx
@@ -3803,7 +3803,7 @@
                 </a:solidFill>
                 <a:latin typeface="Segoe UI Semibold"/>
               </a:rPr>
-              <a:t>Real committed data, running locally, no mock content.</a:t>
+              <a:t>Real local data on the presentation laptop, no mock content.</a:t>
             </a:r>
           </a:p>
         </p:txBody>
@@ -4937,7 +4937,7 @@
                 </a:solidFill>
                 <a:latin typeface="Segoe UI"/>
               </a:rPr>
-              <a:t>Timing collapses 56 to 75 percent while loudness holds, 28 pieces, three corpora, 2000-shuffle null.</a:t>
+              <a:t>Timing collapses 56 to 75 percent while loudness holds; 28/28 pieces decrease (paired p = 3.73 x 10^-9).</a:t>
             </a:r>
           </a:p>
         </p:txBody>
@@ -5013,7 +5013,7 @@
                 </a:solidFill>
                 <a:latin typeface="Segoe UI"/>
               </a:rPr>
-              <a:t>An operational metric that separates human from synthetic choir networks.</a:t>
+              <a:t>Limited evidence in two human pieces and none of 20 synthetic pieces.</a:t>
             </a:r>
           </a:p>
         </p:txBody>
@@ -5165,7 +5165,7 @@
                 </a:solidFill>
                 <a:latin typeface="Segoe UI"/>
               </a:rPr>
-              <a:t>One command, 44 tests, cluster-validated protocol, every claim traceable to a committed artifact.</a:t>
+              <a:t>One command, 48 tests, cluster-validated protocol, every report claim traceable to a committed artifact.</a:t>
             </a:r>
           </a:p>
         </p:txBody>
@@ -5629,7 +5629,7 @@
                 </a:solidFill>
                 <a:latin typeface="Segoe UI"/>
               </a:rPr>
-              <a:t>Final seminar report due Jul 31; draft v1 complete since Jun 30.</a:t>
+              <a:t>Final report ready as Markdown and a 10-page PDF.</a:t>
             </a:r>
           </a:p>
         </p:txBody>
@@ -5926,7 +5926,7 @@
                 </a:solidFill>
                 <a:latin typeface="Segoe UI"/>
               </a:rPr>
-              <a:t>`make reproduce` rebuilds summary results from committed artifacts.</a:t>
+              <a:t>`make reproduce` rebuilds report results and PDF from committed artifacts.</a:t>
             </a:r>
           </a:p>
         </p:txBody>
@@ -7836,7 +7836,7 @@
                 </a:solidFill>
                 <a:latin typeface="Segoe UI"/>
               </a:rPr>
-              <a:t>Every coordination number is tested against a circular-shift null that preserves each stream's own autocorrelation.</a:t>
+              <a:t>Envelope and influence-network results use a circular-shift null that preserves each stream's own autocorrelation.</a:t>
             </a:r>
           </a:p>
           <a:p>
@@ -7906,7 +7906,7 @@
                 </a:solidFill>
                 <a:latin typeface="Segoe UI Semibold"/>
               </a:rPr>
-              <a:t>Known ground truth by construction, paired within piece, with a defensible null.</a:t>
+              <a:t>Known degradation by construction; each piece is its own control.</a:t>
             </a:r>
           </a:p>
         </p:txBody>
@@ -8224,7 +8224,7 @@
                 </a:solidFill>
                 <a:latin typeface="Segoe UI Semibold"/>
               </a:rPr>
-              <a:t>44 tests</a:t>
+              <a:t>48 tests</a:t>
             </a:r>
           </a:p>
           <a:p>
@@ -8240,7 +8240,7 @@
                 </a:solidFill>
                 <a:latin typeface="Segoe UI"/>
               </a:rPr>
-              <a:t>Audio, video, network, latency, entanglement, and the H3 experiment run in the automated suite.</a:t>
+              <a:t>Audio, video, network, latency, entanglement, H3, and report generation run in the automated suite.</a:t>
             </a:r>
           </a:p>
         </p:txBody>
@@ -8900,7 +8900,7 @@
                 </a:solidFill>
                 <a:latin typeface="Segoe UI"/>
               </a:rPr>
-              <a:t>Corpus, 28 pieces</a:t>
+              <a:t>Corpus; 28/28 decrease</a:t>
             </a:r>
           </a:p>
         </p:txBody>
@@ -8978,7 +8978,7 @@
                 </a:solidFill>
                 <a:latin typeface="Segoe UI Semibold"/>
               </a:rPr>
-              <a:t>Onset synchrony collapses clean to Zoom-class; envelope coupling stays flat (Dagstuhl -0.4%).</a:t>
+              <a:t>All 28 pieces decrease (paired p = 3.73 x 10^-9); envelope coupling stays flat.</a:t>
             </a:r>
           </a:p>
         </p:txBody>
@@ -9622,7 +9622,7 @@
                 </a:solidFill>
                 <a:latin typeface="Segoe UI Semibold"/>
               </a:rPr>
-              <a:t>H2: weak but real leadership structure</a:t>
+              <a:t>H2: limited leadership evidence</a:t>
             </a:r>
           </a:p>
         </p:txBody>
@@ -9795,7 +9795,7 @@
                 </a:solidFill>
                 <a:latin typeface="Segoe UI Semibold"/>
               </a:rPr>
-              <a:t>0.154</a:t>
+              <a:t>0.162</a:t>
             </a:r>
           </a:p>
           <a:p>
@@ -9863,7 +9863,7 @@
                 </a:solidFill>
                 <a:latin typeface="Segoe UI Semibold"/>
               </a:rPr>
-              <a:t>0.139</a:t>
+              <a:t>0.155</a:t>
             </a:r>
           </a:p>
           <a:p>
@@ -9931,7 +9931,7 @@
                 </a:solidFill>
                 <a:latin typeface="Segoe UI Semibold"/>
               </a:rPr>
-              <a:t>3/5 - 2/3</a:t>
+              <a:t>1/5 - 1/3</a:t>
             </a:r>
           </a:p>
           <a:p>
@@ -9999,7 +9999,7 @@
                 </a:solidFill>
                 <a:latin typeface="Segoe UI Semibold"/>
               </a:rPr>
-              <a:t>2/20</a:t>
+              <a:t>0/20</a:t>
             </a:r>
           </a:p>
           <a:p>
@@ -10011,7 +10011,7 @@
                 </a:solidFill>
                 <a:latin typeface="Segoe UI"/>
               </a:rPr>
-              <a:t>ChoralSynth (chance)</a:t>
+              <a:t>ChoralSynth significant</a:t>
             </a:r>
           </a:p>
         </p:txBody>
@@ -10089,7 +10089,7 @@
                 </a:solidFill>
                 <a:latin typeface="Segoe UI Semibold"/>
               </a:rPr>
-              <a:t>Leadership appears in human choirs, not synthetic renderings: a human coordination signal, not an artifact.</a:t>
+              <a:t>Limited support: two human pieces are centralized; no synthetic piece is.</a:t>
             </a:r>
           </a:p>
         </p:txBody>

</xml_diff>

<commit_message>
Add IEEE-style report rendering scripts and tests
</commit_message>
<xml_diff>
--- a/output/jul23_final_presentation.pptx
+++ b/output/jul23_final_presentation.pptx
@@ -5,27 +5,27 @@
     <p:sldMasterId id="2147483648" r:id="rId1"/>
   </p:sldMasterIdLst>
   <p:sldIdLst>
-    <p:sldId id="256" r:id="rId7"/>
-    <p:sldId id="257" r:id="rId8"/>
-    <p:sldId id="258" r:id="rId9"/>
-    <p:sldId id="259" r:id="rId10"/>
-    <p:sldId id="260" r:id="rId11"/>
-    <p:sldId id="261" r:id="rId12"/>
-    <p:sldId id="262" r:id="rId13"/>
-    <p:sldId id="263" r:id="rId14"/>
-    <p:sldId id="264" r:id="rId15"/>
-    <p:sldId id="265" r:id="rId16"/>
-    <p:sldId id="266" r:id="rId17"/>
-    <p:sldId id="267" r:id="rId18"/>
-    <p:sldId id="268" r:id="rId19"/>
-    <p:sldId id="269" r:id="rId20"/>
-    <p:sldId id="270" r:id="rId21"/>
-    <p:sldId id="271" r:id="rId22"/>
-    <p:sldId id="272" r:id="rId23"/>
-    <p:sldId id="273" r:id="rId24"/>
-    <p:sldId id="274" r:id="rId25"/>
+    <p:sldId id="256" r:id="rId2"/>
+    <p:sldId id="257" r:id="rId3"/>
+    <p:sldId id="258" r:id="rId4"/>
+    <p:sldId id="259" r:id="rId5"/>
+    <p:sldId id="260" r:id="rId6"/>
+    <p:sldId id="261" r:id="rId7"/>
+    <p:sldId id="262" r:id="rId8"/>
+    <p:sldId id="263" r:id="rId9"/>
+    <p:sldId id="264" r:id="rId10"/>
+    <p:sldId id="265" r:id="rId11"/>
+    <p:sldId id="266" r:id="rId12"/>
+    <p:sldId id="267" r:id="rId13"/>
+    <p:sldId id="268" r:id="rId14"/>
+    <p:sldId id="269" r:id="rId15"/>
+    <p:sldId id="270" r:id="rId16"/>
+    <p:sldId id="271" r:id="rId17"/>
+    <p:sldId id="272" r:id="rId18"/>
+    <p:sldId id="273" r:id="rId19"/>
+    <p:sldId id="274" r:id="rId20"/>
   </p:sldIdLst>
-  <p:sldSz cx="12191695" cy="6858000" type="screen4x3"/>
+  <p:sldSz cx="12192000" cy="6858000"/>
   <p:notesSz cx="6858000" cy="9144000"/>
   <p:defaultTextStyle>
     <a:defPPr>
@@ -122,6 +122,22 @@
       </a:defRPr>
     </a:lvl9pPr>
   </p:defaultTextStyle>
+  <p:extLst>
+    <p:ext uri="{EFAFB233-063F-42B5-8137-9DF3F51BA10A}">
+      <p15:sldGuideLst xmlns:p15="http://schemas.microsoft.com/office/powerpoint/2012/main">
+        <p15:guide id="1" orient="horz" pos="2160">
+          <p15:clr>
+            <a:srgbClr val="A4A3A4"/>
+          </p15:clr>
+        </p15:guide>
+        <p15:guide id="2" pos="2880">
+          <p15:clr>
+            <a:srgbClr val="A4A3A4"/>
+          </p15:clr>
+        </p15:guide>
+      </p15:sldGuideLst>
+    </p:ext>
+  </p:extLst>
 </p:presentation>
 </file>
 
@@ -163,10 +179,9 @@
           <a:lstStyle/>
           <a:p>
             <a:r>
-              <a:rPr lang="en-US" smtClean="0"/>
+              <a:rPr lang="en-US"/>
               <a:t>Click to edit Master title style</a:t>
             </a:r>
-            <a:endParaRPr lang="en-US"/>
           </a:p>
         </p:txBody>
       </p:sp>
@@ -282,10 +297,9 @@
           </a:lstStyle>
           <a:p>
             <a:r>
-              <a:rPr lang="en-US" smtClean="0"/>
+              <a:rPr lang="en-US"/>
               <a:t>Click to edit Master subtitle style</a:t>
             </a:r>
-            <a:endParaRPr lang="en-US"/>
           </a:p>
         </p:txBody>
       </p:sp>
@@ -306,7 +320,7 @@
           <a:p>
             <a:fld id="{5BCAD085-E8A6-8845-BD4E-CB4CCA059FC4}" type="datetimeFigureOut">
               <a:rPr lang="en-US" smtClean="0"/>
-              <a:t>1/27/13</a:t>
+              <a:t>7/22/2026</a:t>
             </a:fld>
             <a:endParaRPr lang="en-US"/>
           </a:p>
@@ -400,10 +414,9 @@
           <a:lstStyle/>
           <a:p>
             <a:r>
-              <a:rPr lang="en-US" smtClean="0"/>
+              <a:rPr lang="en-US"/>
               <a:t>Click to edit Master title style</a:t>
             </a:r>
-            <a:endParaRPr lang="en-US"/>
           </a:p>
         </p:txBody>
       </p:sp>
@@ -424,38 +437,37 @@
           <a:p>
             <a:pPr lvl="0"/>
             <a:r>
-              <a:rPr lang="en-US" smtClean="0"/>
+              <a:rPr lang="en-US"/>
               <a:t>Click to edit Master text styles</a:t>
             </a:r>
           </a:p>
           <a:p>
             <a:pPr lvl="1"/>
             <a:r>
-              <a:rPr lang="en-US" smtClean="0"/>
+              <a:rPr lang="en-US"/>
               <a:t>Second level</a:t>
             </a:r>
           </a:p>
           <a:p>
             <a:pPr lvl="2"/>
             <a:r>
-              <a:rPr lang="en-US" smtClean="0"/>
+              <a:rPr lang="en-US"/>
               <a:t>Third level</a:t>
             </a:r>
           </a:p>
           <a:p>
             <a:pPr lvl="3"/>
             <a:r>
-              <a:rPr lang="en-US" smtClean="0"/>
+              <a:rPr lang="en-US"/>
               <a:t>Fourth level</a:t>
             </a:r>
           </a:p>
           <a:p>
             <a:pPr lvl="4"/>
             <a:r>
-              <a:rPr lang="en-US" smtClean="0"/>
+              <a:rPr lang="en-US"/>
               <a:t>Fifth level</a:t>
             </a:r>
-            <a:endParaRPr lang="en-US"/>
           </a:p>
         </p:txBody>
       </p:sp>
@@ -476,7 +488,7 @@
           <a:p>
             <a:fld id="{5BCAD085-E8A6-8845-BD4E-CB4CCA059FC4}" type="datetimeFigureOut">
               <a:rPr lang="en-US" smtClean="0"/>
-              <a:t>1/27/13</a:t>
+              <a:t>7/22/2026</a:t>
             </a:fld>
             <a:endParaRPr lang="en-US"/>
           </a:p>
@@ -575,10 +587,9 @@
           <a:lstStyle/>
           <a:p>
             <a:r>
-              <a:rPr lang="en-US" smtClean="0"/>
+              <a:rPr lang="en-US"/>
               <a:t>Click to edit Master title style</a:t>
             </a:r>
-            <a:endParaRPr lang="en-US"/>
           </a:p>
         </p:txBody>
       </p:sp>
@@ -604,38 +615,37 @@
           <a:p>
             <a:pPr lvl="0"/>
             <a:r>
-              <a:rPr lang="en-US" smtClean="0"/>
+              <a:rPr lang="en-US"/>
               <a:t>Click to edit Master text styles</a:t>
             </a:r>
           </a:p>
           <a:p>
             <a:pPr lvl="1"/>
             <a:r>
-              <a:rPr lang="en-US" smtClean="0"/>
+              <a:rPr lang="en-US"/>
               <a:t>Second level</a:t>
             </a:r>
           </a:p>
           <a:p>
             <a:pPr lvl="2"/>
             <a:r>
-              <a:rPr lang="en-US" smtClean="0"/>
+              <a:rPr lang="en-US"/>
               <a:t>Third level</a:t>
             </a:r>
           </a:p>
           <a:p>
             <a:pPr lvl="3"/>
             <a:r>
-              <a:rPr lang="en-US" smtClean="0"/>
+              <a:rPr lang="en-US"/>
               <a:t>Fourth level</a:t>
             </a:r>
           </a:p>
           <a:p>
             <a:pPr lvl="4"/>
             <a:r>
-              <a:rPr lang="en-US" smtClean="0"/>
+              <a:rPr lang="en-US"/>
               <a:t>Fifth level</a:t>
             </a:r>
-            <a:endParaRPr lang="en-US"/>
           </a:p>
         </p:txBody>
       </p:sp>
@@ -656,7 +666,7 @@
           <a:p>
             <a:fld id="{5BCAD085-E8A6-8845-BD4E-CB4CCA059FC4}" type="datetimeFigureOut">
               <a:rPr lang="en-US" smtClean="0"/>
-              <a:t>1/27/13</a:t>
+              <a:t>7/22/2026</a:t>
             </a:fld>
             <a:endParaRPr lang="en-US"/>
           </a:p>
@@ -750,10 +760,9 @@
           <a:lstStyle/>
           <a:p>
             <a:r>
-              <a:rPr lang="en-US" smtClean="0"/>
+              <a:rPr lang="en-US"/>
               <a:t>Click to edit Master title style</a:t>
             </a:r>
-            <a:endParaRPr lang="en-US"/>
           </a:p>
         </p:txBody>
       </p:sp>
@@ -774,38 +783,37 @@
           <a:p>
             <a:pPr lvl="0"/>
             <a:r>
-              <a:rPr lang="en-US" smtClean="0"/>
+              <a:rPr lang="en-US"/>
               <a:t>Click to edit Master text styles</a:t>
             </a:r>
           </a:p>
           <a:p>
             <a:pPr lvl="1"/>
             <a:r>
-              <a:rPr lang="en-US" smtClean="0"/>
+              <a:rPr lang="en-US"/>
               <a:t>Second level</a:t>
             </a:r>
           </a:p>
           <a:p>
             <a:pPr lvl="2"/>
             <a:r>
-              <a:rPr lang="en-US" smtClean="0"/>
+              <a:rPr lang="en-US"/>
               <a:t>Third level</a:t>
             </a:r>
           </a:p>
           <a:p>
             <a:pPr lvl="3"/>
             <a:r>
-              <a:rPr lang="en-US" smtClean="0"/>
+              <a:rPr lang="en-US"/>
               <a:t>Fourth level</a:t>
             </a:r>
           </a:p>
           <a:p>
             <a:pPr lvl="4"/>
             <a:r>
-              <a:rPr lang="en-US" smtClean="0"/>
+              <a:rPr lang="en-US"/>
               <a:t>Fifth level</a:t>
             </a:r>
-            <a:endParaRPr lang="en-US"/>
           </a:p>
         </p:txBody>
       </p:sp>
@@ -826,7 +834,7 @@
           <a:p>
             <a:fld id="{5BCAD085-E8A6-8845-BD4E-CB4CCA059FC4}" type="datetimeFigureOut">
               <a:rPr lang="en-US" smtClean="0"/>
-              <a:t>1/27/13</a:t>
+              <a:t>7/22/2026</a:t>
             </a:fld>
             <a:endParaRPr lang="en-US"/>
           </a:p>
@@ -929,10 +937,9 @@
           </a:lstStyle>
           <a:p>
             <a:r>
-              <a:rPr lang="en-US" smtClean="0"/>
+              <a:rPr lang="en-US"/>
               <a:t>Click to edit Master title style</a:t>
             </a:r>
-            <a:endParaRPr lang="en-US"/>
           </a:p>
         </p:txBody>
       </p:sp>
@@ -1049,7 +1056,7 @@
           <a:p>
             <a:pPr lvl="0"/>
             <a:r>
-              <a:rPr lang="en-US" smtClean="0"/>
+              <a:rPr lang="en-US"/>
               <a:t>Click to edit Master text styles</a:t>
             </a:r>
           </a:p>
@@ -1072,7 +1079,7 @@
           <a:p>
             <a:fld id="{5BCAD085-E8A6-8845-BD4E-CB4CCA059FC4}" type="datetimeFigureOut">
               <a:rPr lang="en-US" smtClean="0"/>
-              <a:t>1/27/13</a:t>
+              <a:t>7/22/2026</a:t>
             </a:fld>
             <a:endParaRPr lang="en-US"/>
           </a:p>
@@ -1166,10 +1173,9 @@
           <a:lstStyle/>
           <a:p>
             <a:r>
-              <a:rPr lang="en-US" smtClean="0"/>
+              <a:rPr lang="en-US"/>
               <a:t>Click to edit Master title style</a:t>
             </a:r>
-            <a:endParaRPr lang="en-US"/>
           </a:p>
         </p:txBody>
       </p:sp>
@@ -1223,38 +1229,37 @@
           <a:p>
             <a:pPr lvl="0"/>
             <a:r>
-              <a:rPr lang="en-US" smtClean="0"/>
+              <a:rPr lang="en-US"/>
               <a:t>Click to edit Master text styles</a:t>
             </a:r>
           </a:p>
           <a:p>
             <a:pPr lvl="1"/>
             <a:r>
-              <a:rPr lang="en-US" smtClean="0"/>
+              <a:rPr lang="en-US"/>
               <a:t>Second level</a:t>
             </a:r>
           </a:p>
           <a:p>
             <a:pPr lvl="2"/>
             <a:r>
-              <a:rPr lang="en-US" smtClean="0"/>
+              <a:rPr lang="en-US"/>
               <a:t>Third level</a:t>
             </a:r>
           </a:p>
           <a:p>
             <a:pPr lvl="3"/>
             <a:r>
-              <a:rPr lang="en-US" smtClean="0"/>
+              <a:rPr lang="en-US"/>
               <a:t>Fourth level</a:t>
             </a:r>
           </a:p>
           <a:p>
             <a:pPr lvl="4"/>
             <a:r>
-              <a:rPr lang="en-US" smtClean="0"/>
+              <a:rPr lang="en-US"/>
               <a:t>Fifth level</a:t>
             </a:r>
-            <a:endParaRPr lang="en-US"/>
           </a:p>
         </p:txBody>
       </p:sp>
@@ -1308,38 +1313,37 @@
           <a:p>
             <a:pPr lvl="0"/>
             <a:r>
-              <a:rPr lang="en-US" smtClean="0"/>
+              <a:rPr lang="en-US"/>
               <a:t>Click to edit Master text styles</a:t>
             </a:r>
           </a:p>
           <a:p>
             <a:pPr lvl="1"/>
             <a:r>
-              <a:rPr lang="en-US" smtClean="0"/>
+              <a:rPr lang="en-US"/>
               <a:t>Second level</a:t>
             </a:r>
           </a:p>
           <a:p>
             <a:pPr lvl="2"/>
             <a:r>
-              <a:rPr lang="en-US" smtClean="0"/>
+              <a:rPr lang="en-US"/>
               <a:t>Third level</a:t>
             </a:r>
           </a:p>
           <a:p>
             <a:pPr lvl="3"/>
             <a:r>
-              <a:rPr lang="en-US" smtClean="0"/>
+              <a:rPr lang="en-US"/>
               <a:t>Fourth level</a:t>
             </a:r>
           </a:p>
           <a:p>
             <a:pPr lvl="4"/>
             <a:r>
-              <a:rPr lang="en-US" smtClean="0"/>
+              <a:rPr lang="en-US"/>
               <a:t>Fifth level</a:t>
             </a:r>
-            <a:endParaRPr lang="en-US"/>
           </a:p>
         </p:txBody>
       </p:sp>
@@ -1360,7 +1364,7 @@
           <a:p>
             <a:fld id="{5BCAD085-E8A6-8845-BD4E-CB4CCA059FC4}" type="datetimeFigureOut">
               <a:rPr lang="en-US" smtClean="0"/>
-              <a:t>1/27/13</a:t>
+              <a:t>7/22/2026</a:t>
             </a:fld>
             <a:endParaRPr lang="en-US"/>
           </a:p>
@@ -1458,10 +1462,9 @@
           </a:lstStyle>
           <a:p>
             <a:r>
-              <a:rPr lang="en-US" smtClean="0"/>
+              <a:rPr lang="en-US"/>
               <a:t>Click to edit Master title style</a:t>
             </a:r>
-            <a:endParaRPr lang="en-US"/>
           </a:p>
         </p:txBody>
       </p:sp>
@@ -1524,7 +1527,7 @@
           <a:p>
             <a:pPr lvl="0"/>
             <a:r>
-              <a:rPr lang="en-US" smtClean="0"/>
+              <a:rPr lang="en-US"/>
               <a:t>Click to edit Master text styles</a:t>
             </a:r>
           </a:p>
@@ -1580,38 +1583,37 @@
           <a:p>
             <a:pPr lvl="0"/>
             <a:r>
-              <a:rPr lang="en-US" smtClean="0"/>
+              <a:rPr lang="en-US"/>
               <a:t>Click to edit Master text styles</a:t>
             </a:r>
           </a:p>
           <a:p>
             <a:pPr lvl="1"/>
             <a:r>
-              <a:rPr lang="en-US" smtClean="0"/>
+              <a:rPr lang="en-US"/>
               <a:t>Second level</a:t>
             </a:r>
           </a:p>
           <a:p>
             <a:pPr lvl="2"/>
             <a:r>
-              <a:rPr lang="en-US" smtClean="0"/>
+              <a:rPr lang="en-US"/>
               <a:t>Third level</a:t>
             </a:r>
           </a:p>
           <a:p>
             <a:pPr lvl="3"/>
             <a:r>
-              <a:rPr lang="en-US" smtClean="0"/>
+              <a:rPr lang="en-US"/>
               <a:t>Fourth level</a:t>
             </a:r>
           </a:p>
           <a:p>
             <a:pPr lvl="4"/>
             <a:r>
-              <a:rPr lang="en-US" smtClean="0"/>
+              <a:rPr lang="en-US"/>
               <a:t>Fifth level</a:t>
             </a:r>
-            <a:endParaRPr lang="en-US"/>
           </a:p>
         </p:txBody>
       </p:sp>
@@ -1674,7 +1676,7 @@
           <a:p>
             <a:pPr lvl="0"/>
             <a:r>
-              <a:rPr lang="en-US" smtClean="0"/>
+              <a:rPr lang="en-US"/>
               <a:t>Click to edit Master text styles</a:t>
             </a:r>
           </a:p>
@@ -1730,38 +1732,37 @@
           <a:p>
             <a:pPr lvl="0"/>
             <a:r>
-              <a:rPr lang="en-US" smtClean="0"/>
+              <a:rPr lang="en-US"/>
               <a:t>Click to edit Master text styles</a:t>
             </a:r>
           </a:p>
           <a:p>
             <a:pPr lvl="1"/>
             <a:r>
-              <a:rPr lang="en-US" smtClean="0"/>
+              <a:rPr lang="en-US"/>
               <a:t>Second level</a:t>
             </a:r>
           </a:p>
           <a:p>
             <a:pPr lvl="2"/>
             <a:r>
-              <a:rPr lang="en-US" smtClean="0"/>
+              <a:rPr lang="en-US"/>
               <a:t>Third level</a:t>
             </a:r>
           </a:p>
           <a:p>
             <a:pPr lvl="3"/>
             <a:r>
-              <a:rPr lang="en-US" smtClean="0"/>
+              <a:rPr lang="en-US"/>
               <a:t>Fourth level</a:t>
             </a:r>
           </a:p>
           <a:p>
             <a:pPr lvl="4"/>
             <a:r>
-              <a:rPr lang="en-US" smtClean="0"/>
+              <a:rPr lang="en-US"/>
               <a:t>Fifth level</a:t>
             </a:r>
-            <a:endParaRPr lang="en-US"/>
           </a:p>
         </p:txBody>
       </p:sp>
@@ -1782,7 +1783,7 @@
           <a:p>
             <a:fld id="{5BCAD085-E8A6-8845-BD4E-CB4CCA059FC4}" type="datetimeFigureOut">
               <a:rPr lang="en-US" smtClean="0"/>
-              <a:t>1/27/13</a:t>
+              <a:t>7/22/2026</a:t>
             </a:fld>
             <a:endParaRPr lang="en-US"/>
           </a:p>
@@ -1876,10 +1877,9 @@
           <a:lstStyle/>
           <a:p>
             <a:r>
-              <a:rPr lang="en-US" smtClean="0"/>
+              <a:rPr lang="en-US"/>
               <a:t>Click to edit Master title style</a:t>
             </a:r>
-            <a:endParaRPr lang="en-US"/>
           </a:p>
         </p:txBody>
       </p:sp>
@@ -1900,7 +1900,7 @@
           <a:p>
             <a:fld id="{5BCAD085-E8A6-8845-BD4E-CB4CCA059FC4}" type="datetimeFigureOut">
               <a:rPr lang="en-US" smtClean="0"/>
-              <a:t>1/27/13</a:t>
+              <a:t>7/22/2026</a:t>
             </a:fld>
             <a:endParaRPr lang="en-US"/>
           </a:p>
@@ -1995,7 +1995,7 @@
           <a:p>
             <a:fld id="{5BCAD085-E8A6-8845-BD4E-CB4CCA059FC4}" type="datetimeFigureOut">
               <a:rPr lang="en-US" smtClean="0"/>
-              <a:t>1/27/13</a:t>
+              <a:t>7/22/2026</a:t>
             </a:fld>
             <a:endParaRPr lang="en-US"/>
           </a:p>
@@ -2098,10 +2098,9 @@
           </a:lstStyle>
           <a:p>
             <a:r>
-              <a:rPr lang="en-US" smtClean="0"/>
+              <a:rPr lang="en-US"/>
               <a:t>Click to edit Master title style</a:t>
             </a:r>
-            <a:endParaRPr lang="en-US"/>
           </a:p>
         </p:txBody>
       </p:sp>
@@ -2155,38 +2154,37 @@
           <a:p>
             <a:pPr lvl="0"/>
             <a:r>
-              <a:rPr lang="en-US" smtClean="0"/>
+              <a:rPr lang="en-US"/>
               <a:t>Click to edit Master text styles</a:t>
             </a:r>
           </a:p>
           <a:p>
             <a:pPr lvl="1"/>
             <a:r>
-              <a:rPr lang="en-US" smtClean="0"/>
+              <a:rPr lang="en-US"/>
               <a:t>Second level</a:t>
             </a:r>
           </a:p>
           <a:p>
             <a:pPr lvl="2"/>
             <a:r>
-              <a:rPr lang="en-US" smtClean="0"/>
+              <a:rPr lang="en-US"/>
               <a:t>Third level</a:t>
             </a:r>
           </a:p>
           <a:p>
             <a:pPr lvl="3"/>
             <a:r>
-              <a:rPr lang="en-US" smtClean="0"/>
+              <a:rPr lang="en-US"/>
               <a:t>Fourth level</a:t>
             </a:r>
           </a:p>
           <a:p>
             <a:pPr lvl="4"/>
             <a:r>
-              <a:rPr lang="en-US" smtClean="0"/>
+              <a:rPr lang="en-US"/>
               <a:t>Fifth level</a:t>
             </a:r>
-            <a:endParaRPr lang="en-US"/>
           </a:p>
         </p:txBody>
       </p:sp>
@@ -2249,7 +2247,7 @@
           <a:p>
             <a:pPr lvl="0"/>
             <a:r>
-              <a:rPr lang="en-US" smtClean="0"/>
+              <a:rPr lang="en-US"/>
               <a:t>Click to edit Master text styles</a:t>
             </a:r>
           </a:p>
@@ -2272,7 +2270,7 @@
           <a:p>
             <a:fld id="{5BCAD085-E8A6-8845-BD4E-CB4CCA059FC4}" type="datetimeFigureOut">
               <a:rPr lang="en-US" smtClean="0"/>
-              <a:t>1/27/13</a:t>
+              <a:t>7/22/2026</a:t>
             </a:fld>
             <a:endParaRPr lang="en-US"/>
           </a:p>
@@ -2375,10 +2373,9 @@
           </a:lstStyle>
           <a:p>
             <a:r>
-              <a:rPr lang="en-US" smtClean="0"/>
+              <a:rPr lang="en-US"/>
               <a:t>Click to edit Master title style</a:t>
             </a:r>
-            <a:endParaRPr lang="en-US"/>
           </a:p>
         </p:txBody>
       </p:sp>
@@ -2502,7 +2499,7 @@
           <a:p>
             <a:pPr lvl="0"/>
             <a:r>
-              <a:rPr lang="en-US" smtClean="0"/>
+              <a:rPr lang="en-US"/>
               <a:t>Click to edit Master text styles</a:t>
             </a:r>
           </a:p>
@@ -2525,7 +2522,7 @@
           <a:p>
             <a:fld id="{5BCAD085-E8A6-8845-BD4E-CB4CCA059FC4}" type="datetimeFigureOut">
               <a:rPr lang="en-US" smtClean="0"/>
-              <a:t>1/27/13</a:t>
+              <a:t>7/22/2026</a:t>
             </a:fld>
             <a:endParaRPr lang="en-US"/>
           </a:p>
@@ -2634,10 +2631,9 @@
           <a:lstStyle/>
           <a:p>
             <a:r>
-              <a:rPr lang="en-US" smtClean="0"/>
+              <a:rPr lang="en-US"/>
               <a:t>Click to edit Master title style</a:t>
             </a:r>
-            <a:endParaRPr lang="en-US"/>
           </a:p>
         </p:txBody>
       </p:sp>
@@ -2668,38 +2664,37 @@
           <a:p>
             <a:pPr lvl="0"/>
             <a:r>
-              <a:rPr lang="en-US" smtClean="0"/>
+              <a:rPr lang="en-US"/>
               <a:t>Click to edit Master text styles</a:t>
             </a:r>
           </a:p>
           <a:p>
             <a:pPr lvl="1"/>
             <a:r>
-              <a:rPr lang="en-US" smtClean="0"/>
+              <a:rPr lang="en-US"/>
               <a:t>Second level</a:t>
             </a:r>
           </a:p>
           <a:p>
             <a:pPr lvl="2"/>
             <a:r>
-              <a:rPr lang="en-US" smtClean="0"/>
+              <a:rPr lang="en-US"/>
               <a:t>Third level</a:t>
             </a:r>
           </a:p>
           <a:p>
             <a:pPr lvl="3"/>
             <a:r>
-              <a:rPr lang="en-US" smtClean="0"/>
+              <a:rPr lang="en-US"/>
               <a:t>Fourth level</a:t>
             </a:r>
           </a:p>
           <a:p>
             <a:pPr lvl="4"/>
             <a:r>
-              <a:rPr lang="en-US" smtClean="0"/>
+              <a:rPr lang="en-US"/>
               <a:t>Fifth level</a:t>
             </a:r>
-            <a:endParaRPr lang="en-US"/>
           </a:p>
         </p:txBody>
       </p:sp>
@@ -2738,7 +2733,7 @@
           <a:p>
             <a:fld id="{5BCAD085-E8A6-8845-BD4E-CB4CCA059FC4}" type="datetimeFigureOut">
               <a:rPr lang="en-US" smtClean="0"/>
-              <a:t>1/27/13</a:t>
+              <a:t>7/22/2026</a:t>
             </a:fld>
             <a:endParaRPr lang="en-US"/>
           </a:p>
@@ -3097,7 +3092,7 @@
 </file>
 
 <file path=ppt/slides/slide1.xml><?xml version="1.0" encoding="utf-8"?>
-<p:sld xmlns:a="http://schemas.openxmlformats.org/drawingml/2006/main" xmlns:p="http://schemas.openxmlformats.org/presentationml/2006/main" xmlns:r="http://schemas.openxmlformats.org/officeDocument/2006/relationships">
+<p:sld xmlns:a="http://schemas.openxmlformats.org/drawingml/2006/main" xmlns:r="http://schemas.openxmlformats.org/officeDocument/2006/relationships" xmlns:p="http://schemas.openxmlformats.org/presentationml/2006/main">
   <p:cSld>
     <p:bg>
       <p:bgPr>
@@ -3113,7 +3108,14 @@
         <p:cNvGrpSpPr/>
         <p:nvPr/>
       </p:nvGrpSpPr>
-      <p:grpSpPr/>
+      <p:grpSpPr>
+        <a:xfrm>
+          <a:off x="0" y="0"/>
+          <a:ext cx="0" cy="0"/>
+          <a:chOff x="0" y="0"/>
+          <a:chExt cx="0" cy="0"/>
+        </a:xfrm>
+      </p:grpSpPr>
       <p:sp>
         <p:nvSpPr>
           <p:cNvPr id="2" name="TextBox 1"/>
@@ -3131,7 +3133,7 @@
           <a:noFill/>
         </p:spPr>
         <p:txBody>
-          <a:bodyPr wrap="square" anchor="t" lIns="27432" rIns="27432" tIns="18288" bIns="18288">
+          <a:bodyPr wrap="square" lIns="27432" tIns="18288" rIns="27432" bIns="18288" anchor="t">
             <a:spAutoFit/>
           </a:bodyPr>
           <a:lstStyle/>
@@ -3170,7 +3172,7 @@
           <a:noFill/>
         </p:spPr>
         <p:txBody>
-          <a:bodyPr wrap="square" anchor="t" lIns="27432" rIns="27432" tIns="18288" bIns="18288">
+          <a:bodyPr wrap="square" lIns="27432" tIns="18288" rIns="27432" bIns="18288" anchor="t">
             <a:spAutoFit/>
           </a:bodyPr>
           <a:lstStyle/>
@@ -3209,7 +3211,7 @@
           <a:noFill/>
         </p:spPr>
         <p:txBody>
-          <a:bodyPr wrap="square" anchor="t" lIns="27432" rIns="27432" tIns="18288" bIns="18288">
+          <a:bodyPr wrap="square" lIns="27432" tIns="18288" rIns="27432" bIns="18288" anchor="t">
             <a:spAutoFit/>
           </a:bodyPr>
           <a:lstStyle/>
@@ -3248,7 +3250,7 @@
           <a:noFill/>
         </p:spPr>
         <p:txBody>
-          <a:bodyPr wrap="square" anchor="t" lIns="27432" rIns="27432" tIns="18288" bIns="18288">
+          <a:bodyPr wrap="square" lIns="27432" tIns="18288" rIns="27432" bIns="18288" anchor="t">
             <a:spAutoFit/>
           </a:bodyPr>
           <a:lstStyle/>
@@ -3287,7 +3289,7 @@
           <a:noFill/>
         </p:spPr>
         <p:txBody>
-          <a:bodyPr wrap="square" anchor="t" lIns="27432" rIns="27432" tIns="18288" bIns="18288">
+          <a:bodyPr wrap="square" lIns="27432" tIns="18288" rIns="27432" bIns="18288" anchor="t">
             <a:spAutoFit/>
           </a:bodyPr>
           <a:lstStyle/>
@@ -3318,7 +3320,7 @@
 </file>
 
 <file path=ppt/slides/slide10.xml><?xml version="1.0" encoding="utf-8"?>
-<p:sld xmlns:a="http://schemas.openxmlformats.org/drawingml/2006/main" xmlns:p="http://schemas.openxmlformats.org/presentationml/2006/main" xmlns:r="http://schemas.openxmlformats.org/officeDocument/2006/relationships">
+<p:sld xmlns:a="http://schemas.openxmlformats.org/drawingml/2006/main" xmlns:r="http://schemas.openxmlformats.org/officeDocument/2006/relationships" xmlns:p="http://schemas.openxmlformats.org/presentationml/2006/main">
   <p:cSld>
     <p:bg>
       <p:bgPr>
@@ -3334,7 +3336,14 @@
         <p:cNvGrpSpPr/>
         <p:nvPr/>
       </p:nvGrpSpPr>
-      <p:grpSpPr/>
+      <p:grpSpPr>
+        <a:xfrm>
+          <a:off x="0" y="0"/>
+          <a:ext cx="0" cy="0"/>
+          <a:chOff x="0" y="0"/>
+          <a:chExt cx="0" cy="0"/>
+        </a:xfrm>
+      </p:grpSpPr>
       <p:sp>
         <p:nvSpPr>
           <p:cNvPr id="2" name="TextBox 1"/>
@@ -3352,7 +3361,7 @@
           <a:noFill/>
         </p:spPr>
         <p:txBody>
-          <a:bodyPr wrap="square" anchor="t" lIns="27432" rIns="27432" tIns="18288" bIns="18288">
+          <a:bodyPr wrap="square" lIns="27432" tIns="18288" rIns="27432" bIns="18288" anchor="t">
             <a:spAutoFit/>
           </a:bodyPr>
           <a:lstStyle/>
@@ -3391,7 +3400,7 @@
           <a:noFill/>
         </p:spPr>
         <p:txBody>
-          <a:bodyPr wrap="square" anchor="t" lIns="27432" rIns="27432" tIns="18288" bIns="18288">
+          <a:bodyPr wrap="square" lIns="27432" tIns="18288" rIns="27432" bIns="18288" anchor="t">
             <a:spAutoFit/>
           </a:bodyPr>
           <a:lstStyle/>
@@ -3430,7 +3439,7 @@
           <a:noFill/>
         </p:spPr>
         <p:txBody>
-          <a:bodyPr wrap="square" anchor="t" lIns="27432" rIns="27432" tIns="18288" bIns="18288">
+          <a:bodyPr wrap="square" lIns="27432" tIns="18288" rIns="27432" bIns="18288" anchor="t">
             <a:spAutoFit/>
           </a:bodyPr>
           <a:lstStyle/>
@@ -3469,7 +3478,7 @@
           <a:noFill/>
         </p:spPr>
         <p:txBody>
-          <a:bodyPr wrap="square" anchor="t" lIns="27432" rIns="27432" tIns="18288" bIns="18288">
+          <a:bodyPr wrap="square" lIns="27432" tIns="18288" rIns="27432" bIns="18288" anchor="t">
             <a:spAutoFit/>
           </a:bodyPr>
           <a:lstStyle/>
@@ -3531,7 +3540,7 @@
           </a:fontRef>
         </p:style>
         <p:txBody>
-          <a:bodyPr rtlCol="0" anchor="t" wrap="square" lIns="201168" rIns="201168" tIns="146304"/>
+          <a:bodyPr wrap="square" lIns="201168" tIns="146304" rIns="201168" rtlCol="0" anchor="t"/>
           <a:lstStyle/>
           <a:p>
             <a:pPr algn="l" latinLnBrk="0">
@@ -3607,7 +3616,7 @@
           </a:fontRef>
         </p:style>
         <p:txBody>
-          <a:bodyPr rtlCol="0" anchor="t" wrap="square" lIns="201168" rIns="201168" tIns="146304"/>
+          <a:bodyPr wrap="square" lIns="201168" tIns="146304" rIns="201168" rtlCol="0" anchor="t"/>
           <a:lstStyle/>
           <a:p>
             <a:pPr algn="l" latinLnBrk="0">
@@ -3683,7 +3692,7 @@
           </a:fontRef>
         </p:style>
         <p:txBody>
-          <a:bodyPr rtlCol="0" anchor="t" wrap="square" lIns="201168" rIns="201168" tIns="146304"/>
+          <a:bodyPr wrap="square" lIns="201168" tIns="146304" rIns="201168" rtlCol="0" anchor="t"/>
           <a:lstStyle/>
           <a:p>
             <a:pPr algn="l" latinLnBrk="0">
@@ -3759,7 +3768,7 @@
           </a:fontRef>
         </p:style>
         <p:txBody>
-          <a:bodyPr rtlCol="0" anchor="t" wrap="square" lIns="201168" rIns="201168" tIns="146304"/>
+          <a:bodyPr wrap="square" lIns="201168" tIns="146304" rIns="201168" rtlCol="0" anchor="t"/>
           <a:lstStyle/>
           <a:p>
             <a:pPr algn="l" latinLnBrk="0">
@@ -3803,7 +3812,7 @@
         </p:nvSpPr>
         <p:spPr>
           <a:xfrm>
-            <a:off x="502920" y="6144768"/>
+            <a:off x="502920" y="5979668"/>
             <a:ext cx="11185855" cy="475488"/>
           </a:xfrm>
           <a:prstGeom prst="roundRect">
@@ -3833,7 +3842,7 @@
           </a:fontRef>
         </p:style>
         <p:txBody>
-          <a:bodyPr rtlCol="0" anchor="ctr" wrap="square"/>
+          <a:bodyPr wrap="square" rtlCol="0" anchor="ctr"/>
           <a:lstStyle/>
           <a:p>
             <a:pPr algn="ctr" latinLnBrk="0"/>
@@ -3858,7 +3867,7 @@
 </file>
 
 <file path=ppt/slides/slide11.xml><?xml version="1.0" encoding="utf-8"?>
-<p:sld xmlns:a="http://schemas.openxmlformats.org/drawingml/2006/main" xmlns:p="http://schemas.openxmlformats.org/presentationml/2006/main" xmlns:r="http://schemas.openxmlformats.org/officeDocument/2006/relationships">
+<p:sld xmlns:a="http://schemas.openxmlformats.org/drawingml/2006/main" xmlns:r="http://schemas.openxmlformats.org/officeDocument/2006/relationships" xmlns:p="http://schemas.openxmlformats.org/presentationml/2006/main">
   <p:cSld>
     <p:bg>
       <p:bgPr>
@@ -3874,7 +3883,14 @@
         <p:cNvGrpSpPr/>
         <p:nvPr/>
       </p:nvGrpSpPr>
-      <p:grpSpPr/>
+      <p:grpSpPr>
+        <a:xfrm>
+          <a:off x="0" y="0"/>
+          <a:ext cx="0" cy="0"/>
+          <a:chOff x="0" y="0"/>
+          <a:chExt cx="0" cy="0"/>
+        </a:xfrm>
+      </p:grpSpPr>
       <p:sp>
         <p:nvSpPr>
           <p:cNvPr id="2" name="TextBox 1"/>
@@ -3892,7 +3908,7 @@
           <a:noFill/>
         </p:spPr>
         <p:txBody>
-          <a:bodyPr wrap="square" anchor="t" lIns="27432" rIns="27432" tIns="18288" bIns="18288">
+          <a:bodyPr wrap="square" lIns="27432" tIns="18288" rIns="27432" bIns="18288" anchor="t">
             <a:spAutoFit/>
           </a:bodyPr>
           <a:lstStyle/>
@@ -3931,7 +3947,7 @@
           <a:noFill/>
         </p:spPr>
         <p:txBody>
-          <a:bodyPr wrap="square" anchor="t" lIns="27432" rIns="27432" tIns="18288" bIns="18288">
+          <a:bodyPr wrap="square" lIns="27432" tIns="18288" rIns="27432" bIns="18288" anchor="t">
             <a:spAutoFit/>
           </a:bodyPr>
           <a:lstStyle/>
@@ -3970,7 +3986,7 @@
           <a:noFill/>
         </p:spPr>
         <p:txBody>
-          <a:bodyPr wrap="square" anchor="t" lIns="27432" rIns="27432" tIns="18288" bIns="18288">
+          <a:bodyPr wrap="square" lIns="27432" tIns="18288" rIns="27432" bIns="18288" anchor="t">
             <a:spAutoFit/>
           </a:bodyPr>
           <a:lstStyle/>
@@ -4009,7 +4025,7 @@
           <a:noFill/>
         </p:spPr>
         <p:txBody>
-          <a:bodyPr wrap="square" anchor="t" lIns="27432" rIns="27432" tIns="18288" bIns="18288">
+          <a:bodyPr wrap="square" lIns="27432" tIns="18288" rIns="27432" bIns="18288" anchor="t">
             <a:spAutoFit/>
           </a:bodyPr>
           <a:lstStyle/>
@@ -4071,7 +4087,7 @@
           </a:fontRef>
         </p:style>
         <p:txBody>
-          <a:bodyPr rtlCol="0" anchor="ctr" wrap="square"/>
+          <a:bodyPr wrap="square" rtlCol="0" anchor="ctr"/>
           <a:lstStyle/>
           <a:p>
             <a:pPr algn="ctr" latinLnBrk="0"/>
@@ -4139,7 +4155,7 @@
           </a:fontRef>
         </p:style>
         <p:txBody>
-          <a:bodyPr rtlCol="0" anchor="ctr" wrap="square"/>
+          <a:bodyPr wrap="square" rtlCol="0" anchor="ctr"/>
           <a:lstStyle/>
           <a:p>
             <a:pPr algn="ctr" latinLnBrk="0"/>
@@ -4207,7 +4223,7 @@
           </a:fontRef>
         </p:style>
         <p:txBody>
-          <a:bodyPr rtlCol="0" anchor="ctr" wrap="square"/>
+          <a:bodyPr wrap="square" rtlCol="0" anchor="ctr"/>
           <a:lstStyle/>
           <a:p>
             <a:pPr algn="ctr" latinLnBrk="0"/>
@@ -4275,7 +4291,7 @@
           </a:fontRef>
         </p:style>
         <p:txBody>
-          <a:bodyPr rtlCol="0" anchor="ctr" wrap="square"/>
+          <a:bodyPr wrap="square" rtlCol="0" anchor="ctr"/>
           <a:lstStyle/>
           <a:p>
             <a:pPr algn="ctr" latinLnBrk="0"/>
@@ -4335,7 +4351,7 @@
         </p:nvSpPr>
         <p:spPr>
           <a:xfrm>
-            <a:off x="502920" y="6144768"/>
+            <a:off x="502920" y="5941568"/>
             <a:ext cx="11185855" cy="475488"/>
           </a:xfrm>
           <a:prstGeom prst="roundRect">
@@ -4365,7 +4381,7 @@
           </a:fontRef>
         </p:style>
         <p:txBody>
-          <a:bodyPr rtlCol="0" anchor="ctr" wrap="square"/>
+          <a:bodyPr wrap="square" rtlCol="0" anchor="ctr"/>
           <a:lstStyle/>
           <a:p>
             <a:pPr algn="ctr" latinLnBrk="0"/>
@@ -4390,7 +4406,7 @@
 </file>
 
 <file path=ppt/slides/slide12.xml><?xml version="1.0" encoding="utf-8"?>
-<p:sld xmlns:a="http://schemas.openxmlformats.org/drawingml/2006/main" xmlns:p="http://schemas.openxmlformats.org/presentationml/2006/main" xmlns:r="http://schemas.openxmlformats.org/officeDocument/2006/relationships">
+<p:sld xmlns:a="http://schemas.openxmlformats.org/drawingml/2006/main" xmlns:r="http://schemas.openxmlformats.org/officeDocument/2006/relationships" xmlns:p="http://schemas.openxmlformats.org/presentationml/2006/main">
   <p:cSld>
     <p:bg>
       <p:bgPr>
@@ -4406,7 +4422,14 @@
         <p:cNvGrpSpPr/>
         <p:nvPr/>
       </p:nvGrpSpPr>
-      <p:grpSpPr/>
+      <p:grpSpPr>
+        <a:xfrm>
+          <a:off x="0" y="0"/>
+          <a:ext cx="0" cy="0"/>
+          <a:chOff x="0" y="0"/>
+          <a:chExt cx="0" cy="0"/>
+        </a:xfrm>
+      </p:grpSpPr>
       <p:sp>
         <p:nvSpPr>
           <p:cNvPr id="2" name="TextBox 1"/>
@@ -4424,7 +4447,7 @@
           <a:noFill/>
         </p:spPr>
         <p:txBody>
-          <a:bodyPr wrap="square" anchor="t" lIns="27432" rIns="27432" tIns="18288" bIns="18288">
+          <a:bodyPr wrap="square" lIns="27432" tIns="18288" rIns="27432" bIns="18288" anchor="t">
             <a:spAutoFit/>
           </a:bodyPr>
           <a:lstStyle/>
@@ -4463,7 +4486,7 @@
           <a:noFill/>
         </p:spPr>
         <p:txBody>
-          <a:bodyPr wrap="square" anchor="t" lIns="27432" rIns="27432" tIns="18288" bIns="18288">
+          <a:bodyPr wrap="square" lIns="27432" tIns="18288" rIns="27432" bIns="18288" anchor="t">
             <a:spAutoFit/>
           </a:bodyPr>
           <a:lstStyle/>
@@ -4502,7 +4525,7 @@
           <a:noFill/>
         </p:spPr>
         <p:txBody>
-          <a:bodyPr wrap="square" anchor="t" lIns="27432" rIns="27432" tIns="18288" bIns="18288">
+          <a:bodyPr wrap="square" lIns="27432" tIns="18288" rIns="27432" bIns="18288" anchor="t">
             <a:spAutoFit/>
           </a:bodyPr>
           <a:lstStyle/>
@@ -4541,7 +4564,7 @@
           <a:noFill/>
         </p:spPr>
         <p:txBody>
-          <a:bodyPr wrap="square" anchor="t" lIns="27432" rIns="27432" tIns="18288" bIns="18288">
+          <a:bodyPr wrap="square" lIns="27432" tIns="18288" rIns="27432" bIns="18288" anchor="t">
             <a:spAutoFit/>
           </a:bodyPr>
           <a:lstStyle/>
@@ -4603,7 +4626,7 @@
           </a:fontRef>
         </p:style>
         <p:txBody>
-          <a:bodyPr rtlCol="0" anchor="ctr" wrap="square"/>
+          <a:bodyPr wrap="square" rtlCol="0" anchor="ctr"/>
           <a:lstStyle/>
           <a:p>
             <a:pPr algn="ctr" latinLnBrk="0"/>
@@ -4671,7 +4694,7 @@
           </a:fontRef>
         </p:style>
         <p:txBody>
-          <a:bodyPr rtlCol="0" anchor="ctr" wrap="square"/>
+          <a:bodyPr wrap="square" rtlCol="0" anchor="ctr"/>
           <a:lstStyle/>
           <a:p>
             <a:pPr algn="ctr" latinLnBrk="0"/>
@@ -4739,7 +4762,7 @@
           </a:fontRef>
         </p:style>
         <p:txBody>
-          <a:bodyPr rtlCol="0" anchor="ctr" wrap="square"/>
+          <a:bodyPr wrap="square" rtlCol="0" anchor="ctr"/>
           <a:lstStyle/>
           <a:p>
             <a:pPr algn="ctr" latinLnBrk="0"/>
@@ -4831,7 +4854,7 @@
           </a:fontRef>
         </p:style>
         <p:txBody>
-          <a:bodyPr rtlCol="0" anchor="t" wrap="square" lIns="201168" rIns="201168" tIns="146304"/>
+          <a:bodyPr wrap="square" lIns="201168" tIns="146304" rIns="201168" rtlCol="0" anchor="t"/>
           <a:lstStyle/>
           <a:p>
             <a:pPr algn="l" latinLnBrk="0">
@@ -4875,7 +4898,7 @@
         </p:nvSpPr>
         <p:spPr>
           <a:xfrm>
-            <a:off x="502920" y="6144768"/>
+            <a:off x="502920" y="5979668"/>
             <a:ext cx="11185855" cy="475488"/>
           </a:xfrm>
           <a:prstGeom prst="roundRect">
@@ -4905,7 +4928,7 @@
           </a:fontRef>
         </p:style>
         <p:txBody>
-          <a:bodyPr rtlCol="0" anchor="ctr" wrap="square"/>
+          <a:bodyPr wrap="square" rtlCol="0" anchor="ctr"/>
           <a:lstStyle/>
           <a:p>
             <a:pPr algn="ctr" latinLnBrk="0"/>
@@ -4930,7 +4953,7 @@
 </file>
 
 <file path=ppt/slides/slide13.xml><?xml version="1.0" encoding="utf-8"?>
-<p:sld xmlns:a="http://schemas.openxmlformats.org/drawingml/2006/main" xmlns:p="http://schemas.openxmlformats.org/presentationml/2006/main" xmlns:r="http://schemas.openxmlformats.org/officeDocument/2006/relationships">
+<p:sld xmlns:a="http://schemas.openxmlformats.org/drawingml/2006/main" xmlns:r="http://schemas.openxmlformats.org/officeDocument/2006/relationships" xmlns:p="http://schemas.openxmlformats.org/presentationml/2006/main">
   <p:cSld>
     <p:bg>
       <p:bgPr>
@@ -4946,7 +4969,14 @@
         <p:cNvGrpSpPr/>
         <p:nvPr/>
       </p:nvGrpSpPr>
-      <p:grpSpPr/>
+      <p:grpSpPr>
+        <a:xfrm>
+          <a:off x="0" y="0"/>
+          <a:ext cx="0" cy="0"/>
+          <a:chOff x="0" y="0"/>
+          <a:chExt cx="0" cy="0"/>
+        </a:xfrm>
+      </p:grpSpPr>
       <p:sp>
         <p:nvSpPr>
           <p:cNvPr id="2" name="TextBox 1"/>
@@ -4964,7 +4994,7 @@
           <a:noFill/>
         </p:spPr>
         <p:txBody>
-          <a:bodyPr wrap="square" anchor="t" lIns="27432" rIns="27432" tIns="18288" bIns="18288">
+          <a:bodyPr wrap="square" lIns="27432" tIns="18288" rIns="27432" bIns="18288" anchor="t">
             <a:spAutoFit/>
           </a:bodyPr>
           <a:lstStyle/>
@@ -5003,7 +5033,7 @@
           <a:noFill/>
         </p:spPr>
         <p:txBody>
-          <a:bodyPr wrap="square" anchor="t" lIns="27432" rIns="27432" tIns="18288" bIns="18288">
+          <a:bodyPr wrap="square" lIns="27432" tIns="18288" rIns="27432" bIns="18288" anchor="t">
             <a:spAutoFit/>
           </a:bodyPr>
           <a:lstStyle/>
@@ -5042,7 +5072,7 @@
           <a:noFill/>
         </p:spPr>
         <p:txBody>
-          <a:bodyPr wrap="square" anchor="t" lIns="27432" rIns="27432" tIns="18288" bIns="18288">
+          <a:bodyPr wrap="square" lIns="27432" tIns="18288" rIns="27432" bIns="18288" anchor="t">
             <a:spAutoFit/>
           </a:bodyPr>
           <a:lstStyle/>
@@ -5081,7 +5111,7 @@
           <a:noFill/>
         </p:spPr>
         <p:txBody>
-          <a:bodyPr wrap="square" anchor="t" lIns="27432" rIns="27432" tIns="18288" bIns="18288">
+          <a:bodyPr wrap="square" lIns="27432" tIns="18288" rIns="27432" bIns="18288" anchor="t">
             <a:spAutoFit/>
           </a:bodyPr>
           <a:lstStyle/>
@@ -5143,7 +5173,7 @@
           </a:fontRef>
         </p:style>
         <p:txBody>
-          <a:bodyPr rtlCol="0" anchor="t" wrap="square" lIns="201168" rIns="201168" tIns="146304"/>
+          <a:bodyPr wrap="square" lIns="201168" tIns="146304" rIns="201168" rtlCol="0" anchor="t"/>
           <a:lstStyle/>
           <a:p>
             <a:pPr algn="l" latinLnBrk="0">
@@ -5219,7 +5249,7 @@
           </a:fontRef>
         </p:style>
         <p:txBody>
-          <a:bodyPr rtlCol="0" anchor="t" wrap="square" lIns="201168" rIns="201168" tIns="146304"/>
+          <a:bodyPr wrap="square" lIns="201168" tIns="146304" rIns="201168" rtlCol="0" anchor="t"/>
           <a:lstStyle/>
           <a:p>
             <a:pPr algn="l" latinLnBrk="0">
@@ -5295,7 +5325,7 @@
           </a:fontRef>
         </p:style>
         <p:txBody>
-          <a:bodyPr rtlCol="0" anchor="t" wrap="square" lIns="201168" rIns="201168" tIns="146304"/>
+          <a:bodyPr wrap="square" lIns="201168" tIns="146304" rIns="201168" rtlCol="0" anchor="t"/>
           <a:lstStyle/>
           <a:p>
             <a:pPr algn="l" latinLnBrk="0">
@@ -5339,7 +5369,7 @@
         </p:nvSpPr>
         <p:spPr>
           <a:xfrm>
-            <a:off x="502920" y="6144768"/>
+            <a:off x="502920" y="5935218"/>
             <a:ext cx="11185855" cy="475488"/>
           </a:xfrm>
           <a:prstGeom prst="roundRect">
@@ -5369,7 +5399,7 @@
           </a:fontRef>
         </p:style>
         <p:txBody>
-          <a:bodyPr rtlCol="0" anchor="ctr" wrap="square"/>
+          <a:bodyPr wrap="square" rtlCol="0" anchor="ctr"/>
           <a:lstStyle/>
           <a:p>
             <a:pPr algn="ctr" latinLnBrk="0"/>
@@ -5394,7 +5424,7 @@
 </file>
 
 <file path=ppt/slides/slide14.xml><?xml version="1.0" encoding="utf-8"?>
-<p:sld xmlns:a="http://schemas.openxmlformats.org/drawingml/2006/main" xmlns:p="http://schemas.openxmlformats.org/presentationml/2006/main" xmlns:r="http://schemas.openxmlformats.org/officeDocument/2006/relationships">
+<p:sld xmlns:a="http://schemas.openxmlformats.org/drawingml/2006/main" xmlns:r="http://schemas.openxmlformats.org/officeDocument/2006/relationships" xmlns:p="http://schemas.openxmlformats.org/presentationml/2006/main">
   <p:cSld>
     <p:bg>
       <p:bgPr>
@@ -5410,7 +5440,14 @@
         <p:cNvGrpSpPr/>
         <p:nvPr/>
       </p:nvGrpSpPr>
-      <p:grpSpPr/>
+      <p:grpSpPr>
+        <a:xfrm>
+          <a:off x="0" y="0"/>
+          <a:ext cx="0" cy="0"/>
+          <a:chOff x="0" y="0"/>
+          <a:chExt cx="0" cy="0"/>
+        </a:xfrm>
+      </p:grpSpPr>
       <p:sp>
         <p:nvSpPr>
           <p:cNvPr id="2" name="TextBox 1"/>
@@ -5428,7 +5465,7 @@
           <a:noFill/>
         </p:spPr>
         <p:txBody>
-          <a:bodyPr wrap="square" anchor="t" lIns="27432" rIns="27432" tIns="18288" bIns="18288">
+          <a:bodyPr wrap="square" lIns="27432" tIns="18288" rIns="27432" bIns="18288" anchor="t">
             <a:spAutoFit/>
           </a:bodyPr>
           <a:lstStyle/>
@@ -5467,7 +5504,7 @@
           <a:noFill/>
         </p:spPr>
         <p:txBody>
-          <a:bodyPr wrap="square" anchor="t" lIns="27432" rIns="27432" tIns="18288" bIns="18288">
+          <a:bodyPr wrap="square" lIns="27432" tIns="18288" rIns="27432" bIns="18288" anchor="t">
             <a:spAutoFit/>
           </a:bodyPr>
           <a:lstStyle/>
@@ -5506,7 +5543,7 @@
           <a:noFill/>
         </p:spPr>
         <p:txBody>
-          <a:bodyPr wrap="square" anchor="t" lIns="27432" rIns="27432" tIns="18288" bIns="18288">
+          <a:bodyPr wrap="square" lIns="27432" tIns="18288" rIns="27432" bIns="18288" anchor="t">
             <a:spAutoFit/>
           </a:bodyPr>
           <a:lstStyle/>
@@ -5545,7 +5582,7 @@
           <a:noFill/>
         </p:spPr>
         <p:txBody>
-          <a:bodyPr wrap="square" anchor="t" lIns="27432" rIns="27432" tIns="18288" bIns="18288">
+          <a:bodyPr wrap="square" lIns="27432" tIns="18288" rIns="27432" bIns="18288" anchor="t">
             <a:spAutoFit/>
           </a:bodyPr>
           <a:lstStyle/>
@@ -5607,7 +5644,7 @@
           </a:fontRef>
         </p:style>
         <p:txBody>
-          <a:bodyPr rtlCol="0" anchor="t" wrap="square" lIns="201168" rIns="201168" tIns="146304"/>
+          <a:bodyPr wrap="square" lIns="201168" tIns="146304" rIns="201168" rtlCol="0" anchor="t"/>
           <a:lstStyle/>
           <a:p>
             <a:pPr algn="l" latinLnBrk="0">
@@ -5683,7 +5720,7 @@
           </a:fontRef>
         </p:style>
         <p:txBody>
-          <a:bodyPr rtlCol="0" anchor="t" wrap="square" lIns="201168" rIns="201168" tIns="146304"/>
+          <a:bodyPr wrap="square" lIns="201168" tIns="146304" rIns="201168" rtlCol="0" anchor="t"/>
           <a:lstStyle/>
           <a:p>
             <a:pPr algn="l" latinLnBrk="0">
@@ -5759,7 +5796,7 @@
           </a:fontRef>
         </p:style>
         <p:txBody>
-          <a:bodyPr rtlCol="0" anchor="t" wrap="square" lIns="201168" rIns="201168" tIns="146304"/>
+          <a:bodyPr wrap="square" lIns="201168" tIns="146304" rIns="201168" rtlCol="0" anchor="t"/>
           <a:lstStyle/>
           <a:p>
             <a:pPr algn="l" latinLnBrk="0">
@@ -5835,7 +5872,7 @@
           </a:fontRef>
         </p:style>
         <p:txBody>
-          <a:bodyPr rtlCol="0" anchor="t" wrap="square" lIns="201168" rIns="201168" tIns="146304"/>
+          <a:bodyPr wrap="square" lIns="201168" tIns="146304" rIns="201168" rtlCol="0" anchor="t"/>
           <a:lstStyle/>
           <a:p>
             <a:pPr algn="l" latinLnBrk="0">
@@ -5911,7 +5948,7 @@
           </a:fontRef>
         </p:style>
         <p:txBody>
-          <a:bodyPr rtlCol="0" anchor="t" wrap="square" lIns="201168" rIns="201168" tIns="146304"/>
+          <a:bodyPr wrap="square" lIns="201168" tIns="146304" rIns="201168" rtlCol="0" anchor="t"/>
           <a:lstStyle/>
           <a:p>
             <a:pPr algn="l" latinLnBrk="0">
@@ -5956,7 +5993,7 @@
 </file>
 
 <file path=ppt/slides/slide15.xml><?xml version="1.0" encoding="utf-8"?>
-<p:sld xmlns:a="http://schemas.openxmlformats.org/drawingml/2006/main" xmlns:p="http://schemas.openxmlformats.org/presentationml/2006/main" xmlns:r="http://schemas.openxmlformats.org/officeDocument/2006/relationships">
+<p:sld xmlns:a="http://schemas.openxmlformats.org/drawingml/2006/main" xmlns:r="http://schemas.openxmlformats.org/officeDocument/2006/relationships" xmlns:p="http://schemas.openxmlformats.org/presentationml/2006/main">
   <p:cSld>
     <p:bg>
       <p:bgPr>
@@ -5972,7 +6009,14 @@
         <p:cNvGrpSpPr/>
         <p:nvPr/>
       </p:nvGrpSpPr>
-      <p:grpSpPr/>
+      <p:grpSpPr>
+        <a:xfrm>
+          <a:off x="0" y="0"/>
+          <a:ext cx="0" cy="0"/>
+          <a:chOff x="0" y="0"/>
+          <a:chExt cx="0" cy="0"/>
+        </a:xfrm>
+      </p:grpSpPr>
       <p:sp>
         <p:nvSpPr>
           <p:cNvPr id="2" name="TextBox 1"/>
@@ -5990,7 +6034,7 @@
           <a:noFill/>
         </p:spPr>
         <p:txBody>
-          <a:bodyPr wrap="square" anchor="t" lIns="27432" rIns="27432" tIns="18288" bIns="18288">
+          <a:bodyPr wrap="square" lIns="27432" tIns="18288" rIns="27432" bIns="18288" anchor="t">
             <a:spAutoFit/>
           </a:bodyPr>
           <a:lstStyle/>
@@ -6029,7 +6073,7 @@
           <a:noFill/>
         </p:spPr>
         <p:txBody>
-          <a:bodyPr wrap="square" anchor="t" lIns="27432" rIns="27432" tIns="18288" bIns="18288">
+          <a:bodyPr wrap="square" lIns="27432" tIns="18288" rIns="27432" bIns="18288" anchor="t">
             <a:spAutoFit/>
           </a:bodyPr>
           <a:lstStyle/>
@@ -6068,7 +6112,7 @@
           <a:noFill/>
         </p:spPr>
         <p:txBody>
-          <a:bodyPr wrap="square" anchor="t" lIns="27432" rIns="27432" tIns="18288" bIns="18288">
+          <a:bodyPr wrap="square" lIns="27432" tIns="18288" rIns="27432" bIns="18288" anchor="t">
             <a:spAutoFit/>
           </a:bodyPr>
           <a:lstStyle/>
@@ -6107,7 +6151,7 @@
           <a:noFill/>
         </p:spPr>
         <p:txBody>
-          <a:bodyPr wrap="square" anchor="t" lIns="27432" rIns="27432" tIns="18288" bIns="18288">
+          <a:bodyPr wrap="square" lIns="27432" tIns="18288" rIns="27432" bIns="18288" anchor="t">
             <a:spAutoFit/>
           </a:bodyPr>
           <a:lstStyle/>
@@ -6169,7 +6213,7 @@
           </a:fontRef>
         </p:style>
         <p:txBody>
-          <a:bodyPr rtlCol="0" anchor="t" wrap="square" lIns="201168" rIns="201168" tIns="146304"/>
+          <a:bodyPr wrap="square" lIns="201168" tIns="146304" rIns="201168" rtlCol="0" anchor="t"/>
           <a:lstStyle/>
           <a:p>
             <a:pPr algn="l" latinLnBrk="0">
@@ -6245,7 +6289,7 @@
           </a:fontRef>
         </p:style>
         <p:txBody>
-          <a:bodyPr rtlCol="0" anchor="t" wrap="square" lIns="201168" rIns="201168" tIns="146304"/>
+          <a:bodyPr wrap="square" lIns="201168" tIns="146304" rIns="201168" rtlCol="0" anchor="t"/>
           <a:lstStyle/>
           <a:p>
             <a:pPr algn="l" latinLnBrk="0">
@@ -6321,7 +6365,7 @@
           </a:fontRef>
         </p:style>
         <p:txBody>
-          <a:bodyPr rtlCol="0" anchor="t" wrap="square" lIns="201168" rIns="201168" tIns="146304"/>
+          <a:bodyPr wrap="square" lIns="201168" tIns="146304" rIns="201168" rtlCol="0" anchor="t"/>
           <a:lstStyle/>
           <a:p>
             <a:pPr algn="l" latinLnBrk="0">
@@ -6397,7 +6441,7 @@
           </a:fontRef>
         </p:style>
         <p:txBody>
-          <a:bodyPr rtlCol="0" anchor="t" wrap="square" lIns="201168" rIns="201168" tIns="146304"/>
+          <a:bodyPr wrap="square" lIns="201168" tIns="146304" rIns="201168" rtlCol="0" anchor="t"/>
           <a:lstStyle/>
           <a:p>
             <a:pPr algn="l" latinLnBrk="0">
@@ -6442,7 +6486,7 @@
 </file>
 
 <file path=ppt/slides/slide16.xml><?xml version="1.0" encoding="utf-8"?>
-<p:sld xmlns:a="http://schemas.openxmlformats.org/drawingml/2006/main" xmlns:p="http://schemas.openxmlformats.org/presentationml/2006/main" xmlns:r="http://schemas.openxmlformats.org/officeDocument/2006/relationships">
+<p:sld xmlns:a="http://schemas.openxmlformats.org/drawingml/2006/main" xmlns:r="http://schemas.openxmlformats.org/officeDocument/2006/relationships" xmlns:p="http://schemas.openxmlformats.org/presentationml/2006/main">
   <p:cSld>
     <p:bg>
       <p:bgPr>
@@ -6458,7 +6502,14 @@
         <p:cNvGrpSpPr/>
         <p:nvPr/>
       </p:nvGrpSpPr>
-      <p:grpSpPr/>
+      <p:grpSpPr>
+        <a:xfrm>
+          <a:off x="0" y="0"/>
+          <a:ext cx="0" cy="0"/>
+          <a:chOff x="0" y="0"/>
+          <a:chExt cx="0" cy="0"/>
+        </a:xfrm>
+      </p:grpSpPr>
       <p:sp>
         <p:nvSpPr>
           <p:cNvPr id="2" name="TextBox 1"/>
@@ -6476,7 +6527,7 @@
           <a:noFill/>
         </p:spPr>
         <p:txBody>
-          <a:bodyPr wrap="square" anchor="t" lIns="27432" rIns="27432" tIns="18288" bIns="18288">
+          <a:bodyPr wrap="square" lIns="27432" tIns="18288" rIns="27432" bIns="18288" anchor="t">
             <a:spAutoFit/>
           </a:bodyPr>
           <a:lstStyle/>
@@ -6515,7 +6566,7 @@
           <a:noFill/>
         </p:spPr>
         <p:txBody>
-          <a:bodyPr wrap="square" anchor="t" lIns="27432" rIns="27432" tIns="18288" bIns="18288">
+          <a:bodyPr wrap="square" lIns="27432" tIns="18288" rIns="27432" bIns="18288" anchor="t">
             <a:spAutoFit/>
           </a:bodyPr>
           <a:lstStyle/>
@@ -6554,7 +6605,7 @@
           <a:noFill/>
         </p:spPr>
         <p:txBody>
-          <a:bodyPr wrap="square" anchor="t" lIns="27432" rIns="27432" tIns="18288" bIns="18288">
+          <a:bodyPr wrap="square" lIns="27432" tIns="18288" rIns="27432" bIns="18288" anchor="t">
             <a:spAutoFit/>
           </a:bodyPr>
           <a:lstStyle/>
@@ -6593,7 +6644,7 @@
           <a:noFill/>
         </p:spPr>
         <p:txBody>
-          <a:bodyPr wrap="square" anchor="t" lIns="27432" rIns="27432" tIns="18288" bIns="18288">
+          <a:bodyPr wrap="square" lIns="27432" tIns="18288" rIns="27432" bIns="18288" anchor="t">
             <a:spAutoFit/>
           </a:bodyPr>
           <a:lstStyle/>
@@ -6655,7 +6706,7 @@
           </a:fontRef>
         </p:style>
         <p:txBody>
-          <a:bodyPr rtlCol="0" anchor="t" wrap="square" lIns="201168" rIns="201168" tIns="146304"/>
+          <a:bodyPr wrap="square" lIns="201168" tIns="146304" rIns="201168" rtlCol="0" anchor="t"/>
           <a:lstStyle/>
           <a:p>
             <a:pPr algn="l" latinLnBrk="0">
@@ -6731,7 +6782,7 @@
           </a:fontRef>
         </p:style>
         <p:txBody>
-          <a:bodyPr rtlCol="0" anchor="t" wrap="square" lIns="201168" rIns="201168" tIns="146304"/>
+          <a:bodyPr wrap="square" lIns="201168" tIns="146304" rIns="201168" rtlCol="0" anchor="t"/>
           <a:lstStyle/>
           <a:p>
             <a:pPr algn="l" latinLnBrk="0">
@@ -6807,7 +6858,7 @@
           </a:fontRef>
         </p:style>
         <p:txBody>
-          <a:bodyPr rtlCol="0" anchor="t" wrap="square" lIns="201168" rIns="201168" tIns="146304"/>
+          <a:bodyPr wrap="square" lIns="201168" tIns="146304" rIns="201168" rtlCol="0" anchor="t"/>
           <a:lstStyle/>
           <a:p>
             <a:pPr algn="l" latinLnBrk="0">
@@ -6883,7 +6934,7 @@
           </a:fontRef>
         </p:style>
         <p:txBody>
-          <a:bodyPr rtlCol="0" anchor="t" wrap="square" lIns="201168" rIns="201168" tIns="146304"/>
+          <a:bodyPr wrap="square" lIns="201168" tIns="146304" rIns="201168" rtlCol="0" anchor="t"/>
           <a:lstStyle/>
           <a:p>
             <a:pPr algn="l" latinLnBrk="0">
@@ -6928,7 +6979,7 @@
 </file>
 
 <file path=ppt/slides/slide17.xml><?xml version="1.0" encoding="utf-8"?>
-<p:sld xmlns:a="http://schemas.openxmlformats.org/drawingml/2006/main" xmlns:p="http://schemas.openxmlformats.org/presentationml/2006/main" xmlns:r="http://schemas.openxmlformats.org/officeDocument/2006/relationships">
+<p:sld xmlns:a="http://schemas.openxmlformats.org/drawingml/2006/main" xmlns:r="http://schemas.openxmlformats.org/officeDocument/2006/relationships" xmlns:p="http://schemas.openxmlformats.org/presentationml/2006/main">
   <p:cSld>
     <p:bg>
       <p:bgPr>
@@ -6944,7 +6995,14 @@
         <p:cNvGrpSpPr/>
         <p:nvPr/>
       </p:nvGrpSpPr>
-      <p:grpSpPr/>
+      <p:grpSpPr>
+        <a:xfrm>
+          <a:off x="0" y="0"/>
+          <a:ext cx="0" cy="0"/>
+          <a:chOff x="0" y="0"/>
+          <a:chExt cx="0" cy="0"/>
+        </a:xfrm>
+      </p:grpSpPr>
       <p:sp>
         <p:nvSpPr>
           <p:cNvPr id="2" name="TextBox 1"/>
@@ -6962,7 +7020,7 @@
           <a:noFill/>
         </p:spPr>
         <p:txBody>
-          <a:bodyPr wrap="square" anchor="t" lIns="27432" rIns="27432" tIns="18288" bIns="18288">
+          <a:bodyPr wrap="square" lIns="27432" tIns="18288" rIns="27432" bIns="18288" anchor="t">
             <a:spAutoFit/>
           </a:bodyPr>
           <a:lstStyle/>
@@ -7001,7 +7059,7 @@
           <a:noFill/>
         </p:spPr>
         <p:txBody>
-          <a:bodyPr wrap="square" anchor="t" lIns="27432" rIns="27432" tIns="18288" bIns="18288">
+          <a:bodyPr wrap="square" lIns="27432" tIns="18288" rIns="27432" bIns="18288" anchor="t">
             <a:spAutoFit/>
           </a:bodyPr>
           <a:lstStyle/>
@@ -7040,7 +7098,7 @@
           <a:noFill/>
         </p:spPr>
         <p:txBody>
-          <a:bodyPr wrap="square" anchor="t" lIns="27432" rIns="27432" tIns="18288" bIns="18288">
+          <a:bodyPr wrap="square" lIns="27432" tIns="18288" rIns="27432" bIns="18288" anchor="t">
             <a:spAutoFit/>
           </a:bodyPr>
           <a:lstStyle/>
@@ -7079,7 +7137,7 @@
           <a:noFill/>
         </p:spPr>
         <p:txBody>
-          <a:bodyPr wrap="square" anchor="t" lIns="27432" rIns="27432" tIns="18288" bIns="18288">
+          <a:bodyPr wrap="square" lIns="27432" tIns="18288" rIns="27432" bIns="18288" anchor="t">
             <a:spAutoFit/>
           </a:bodyPr>
           <a:lstStyle/>
@@ -7141,7 +7199,7 @@
           </a:fontRef>
         </p:style>
         <p:txBody>
-          <a:bodyPr rtlCol="0" anchor="t" wrap="square" lIns="201168" rIns="201168" tIns="146304"/>
+          <a:bodyPr wrap="square" lIns="201168" tIns="146304" rIns="201168" rtlCol="0" anchor="t"/>
           <a:lstStyle/>
           <a:p>
             <a:pPr algn="l" latinLnBrk="0">
@@ -7219,7 +7277,7 @@
           </a:fontRef>
         </p:style>
         <p:txBody>
-          <a:bodyPr rtlCol="0" anchor="t" wrap="square" lIns="201168" rIns="201168" tIns="146304"/>
+          <a:bodyPr wrap="square" lIns="201168" tIns="146304" rIns="201168" rtlCol="0" anchor="t"/>
           <a:lstStyle/>
           <a:p>
             <a:pPr algn="l" latinLnBrk="0">
@@ -7274,7 +7332,7 @@
           <a:noFill/>
         </p:spPr>
         <p:txBody>
-          <a:bodyPr wrap="square" anchor="t" lIns="27432" rIns="27432" tIns="18288" bIns="18288">
+          <a:bodyPr wrap="square" lIns="27432" tIns="18288" rIns="27432" bIns="18288" anchor="t">
             <a:spAutoFit/>
           </a:bodyPr>
           <a:lstStyle/>
@@ -7305,7 +7363,7 @@
 </file>
 
 <file path=ppt/slides/slide18.xml><?xml version="1.0" encoding="utf-8"?>
-<p:sld xmlns:a="http://schemas.openxmlformats.org/drawingml/2006/main" xmlns:p="http://schemas.openxmlformats.org/presentationml/2006/main" xmlns:r="http://schemas.openxmlformats.org/officeDocument/2006/relationships">
+<p:sld xmlns:a="http://schemas.openxmlformats.org/drawingml/2006/main" xmlns:r="http://schemas.openxmlformats.org/officeDocument/2006/relationships" xmlns:p="http://schemas.openxmlformats.org/presentationml/2006/main">
   <p:cSld>
     <p:bg>
       <p:bgPr>
@@ -7321,7 +7379,14 @@
         <p:cNvGrpSpPr/>
         <p:nvPr/>
       </p:nvGrpSpPr>
-      <p:grpSpPr/>
+      <p:grpSpPr>
+        <a:xfrm>
+          <a:off x="0" y="0"/>
+          <a:ext cx="0" cy="0"/>
+          <a:chOff x="0" y="0"/>
+          <a:chExt cx="0" cy="0"/>
+        </a:xfrm>
+      </p:grpSpPr>
       <p:sp>
         <p:nvSpPr>
           <p:cNvPr id="2" name="TextBox 1"/>
@@ -7339,7 +7404,7 @@
           <a:noFill/>
         </p:spPr>
         <p:txBody>
-          <a:bodyPr wrap="square" anchor="t" lIns="27432" rIns="27432" tIns="18288" bIns="18288">
+          <a:bodyPr wrap="square" lIns="27432" tIns="18288" rIns="27432" bIns="18288" anchor="t">
             <a:spAutoFit/>
           </a:bodyPr>
           <a:lstStyle/>
@@ -7378,7 +7443,7 @@
           <a:noFill/>
         </p:spPr>
         <p:txBody>
-          <a:bodyPr wrap="square" anchor="t" lIns="27432" rIns="27432" tIns="18288" bIns="18288">
+          <a:bodyPr wrap="square" lIns="27432" tIns="18288" rIns="27432" bIns="18288" anchor="t">
             <a:spAutoFit/>
           </a:bodyPr>
           <a:lstStyle/>
@@ -7417,7 +7482,7 @@
           <a:noFill/>
         </p:spPr>
         <p:txBody>
-          <a:bodyPr wrap="square" anchor="t" lIns="27432" rIns="27432" tIns="18288" bIns="18288">
+          <a:bodyPr wrap="square" lIns="27432" tIns="18288" rIns="27432" bIns="18288" anchor="t">
             <a:spAutoFit/>
           </a:bodyPr>
           <a:lstStyle/>
@@ -7456,7 +7521,7 @@
           <a:noFill/>
         </p:spPr>
         <p:txBody>
-          <a:bodyPr wrap="square" anchor="t" lIns="27432" rIns="27432" tIns="18288" bIns="18288">
+          <a:bodyPr wrap="square" lIns="27432" tIns="18288" rIns="27432" bIns="18288" anchor="t">
             <a:spAutoFit/>
           </a:bodyPr>
           <a:lstStyle/>
@@ -7502,60 +7567,6 @@
           </a:prstGeom>
         </p:spPr>
       </p:pic>
-      <p:sp>
-        <p:nvSpPr>
-          <p:cNvPr id="7" name="Rounded Rectangle 6"/>
-          <p:cNvSpPr/>
-          <p:nvPr/>
-        </p:nvSpPr>
-        <p:spPr>
-          <a:xfrm>
-            <a:off x="502920" y="6144768"/>
-            <a:ext cx="11185855" cy="475488"/>
-          </a:xfrm>
-          <a:prstGeom prst="roundRect">
-            <a:avLst>
-              <a:gd name="adj" fmla="val 6000"/>
-            </a:avLst>
-          </a:prstGeom>
-          <a:solidFill>
-            <a:srgbClr val="0E4D5E"/>
-          </a:solidFill>
-          <a:ln>
-            <a:noFill/>
-          </a:ln>
-        </p:spPr>
-        <p:style>
-          <a:lnRef idx="1">
-            <a:schemeClr val="accent1"/>
-          </a:lnRef>
-          <a:fillRef idx="3">
-            <a:schemeClr val="accent1"/>
-          </a:fillRef>
-          <a:effectRef idx="2">
-            <a:schemeClr val="accent1"/>
-          </a:effectRef>
-          <a:fontRef idx="minor">
-            <a:schemeClr val="lt1"/>
-          </a:fontRef>
-        </p:style>
-        <p:txBody>
-          <a:bodyPr rtlCol="0" anchor="ctr" wrap="square"/>
-          <a:lstStyle/>
-          <a:p>
-            <a:pPr algn="ctr" latinLnBrk="0"/>
-            <a:r>
-              <a:rPr sz="1400" b="1">
-                <a:solidFill>
-                  <a:srgbClr val="FDFBF5"/>
-                </a:solidFill>
-                <a:latin typeface="Segoe UI Semibold"/>
-              </a:rPr>
-              <a:t>Use only if the live dashboard cannot run.</a:t>
-            </a:r>
-          </a:p>
-        </p:txBody>
-      </p:sp>
     </p:spTree>
   </p:cSld>
   <p:clrMapOvr>
@@ -7565,7 +7576,7 @@
 </file>
 
 <file path=ppt/slides/slide19.xml><?xml version="1.0" encoding="utf-8"?>
-<p:sld xmlns:a="http://schemas.openxmlformats.org/drawingml/2006/main" xmlns:p="http://schemas.openxmlformats.org/presentationml/2006/main" xmlns:r="http://schemas.openxmlformats.org/officeDocument/2006/relationships">
+<p:sld xmlns:a="http://schemas.openxmlformats.org/drawingml/2006/main" xmlns:r="http://schemas.openxmlformats.org/officeDocument/2006/relationships" xmlns:p="http://schemas.openxmlformats.org/presentationml/2006/main">
   <p:cSld>
     <p:bg>
       <p:bgPr>
@@ -7581,7 +7592,14 @@
         <p:cNvGrpSpPr/>
         <p:nvPr/>
       </p:nvGrpSpPr>
-      <p:grpSpPr/>
+      <p:grpSpPr>
+        <a:xfrm>
+          <a:off x="0" y="0"/>
+          <a:ext cx="0" cy="0"/>
+          <a:chOff x="0" y="0"/>
+          <a:chExt cx="0" cy="0"/>
+        </a:xfrm>
+      </p:grpSpPr>
       <p:sp>
         <p:nvSpPr>
           <p:cNvPr id="2" name="TextBox 1"/>
@@ -7599,7 +7617,7 @@
           <a:noFill/>
         </p:spPr>
         <p:txBody>
-          <a:bodyPr wrap="square" anchor="t" lIns="27432" rIns="27432" tIns="18288" bIns="18288">
+          <a:bodyPr wrap="square" lIns="27432" tIns="18288" rIns="27432" bIns="18288" anchor="t">
             <a:spAutoFit/>
           </a:bodyPr>
           <a:lstStyle/>
@@ -7638,7 +7656,7 @@
           <a:noFill/>
         </p:spPr>
         <p:txBody>
-          <a:bodyPr wrap="square" anchor="t" lIns="27432" rIns="27432" tIns="18288" bIns="18288">
+          <a:bodyPr wrap="square" lIns="27432" tIns="18288" rIns="27432" bIns="18288" anchor="t">
             <a:spAutoFit/>
           </a:bodyPr>
           <a:lstStyle/>
@@ -7677,7 +7695,7 @@
           <a:noFill/>
         </p:spPr>
         <p:txBody>
-          <a:bodyPr wrap="square" anchor="t" lIns="27432" rIns="27432" tIns="18288" bIns="18288">
+          <a:bodyPr wrap="square" lIns="27432" tIns="18288" rIns="27432" bIns="18288" anchor="t">
             <a:spAutoFit/>
           </a:bodyPr>
           <a:lstStyle/>
@@ -7716,7 +7734,7 @@
           <a:noFill/>
         </p:spPr>
         <p:txBody>
-          <a:bodyPr wrap="square" anchor="t" lIns="27432" rIns="27432" tIns="18288" bIns="18288">
+          <a:bodyPr wrap="square" lIns="27432" tIns="18288" rIns="27432" bIns="18288" anchor="t">
             <a:spAutoFit/>
           </a:bodyPr>
           <a:lstStyle/>
@@ -7778,7 +7796,7 @@
           </a:fontRef>
         </p:style>
         <p:txBody>
-          <a:bodyPr rtlCol="0" anchor="t" wrap="square" lIns="201168" rIns="201168" tIns="146304"/>
+          <a:bodyPr wrap="square" lIns="201168" tIns="146304" rIns="201168" rtlCol="0" anchor="t"/>
           <a:lstStyle/>
           <a:p>
             <a:pPr algn="l" latinLnBrk="0">
@@ -7854,7 +7872,7 @@
           </a:fontRef>
         </p:style>
         <p:txBody>
-          <a:bodyPr rtlCol="0" anchor="t" wrap="square" lIns="201168" rIns="201168" tIns="146304"/>
+          <a:bodyPr wrap="square" lIns="201168" tIns="146304" rIns="201168" rtlCol="0" anchor="t"/>
           <a:lstStyle/>
           <a:p>
             <a:pPr algn="l" latinLnBrk="0">
@@ -7930,7 +7948,7 @@
           </a:fontRef>
         </p:style>
         <p:txBody>
-          <a:bodyPr rtlCol="0" anchor="t" wrap="square" lIns="201168" rIns="201168" tIns="146304"/>
+          <a:bodyPr wrap="square" lIns="201168" tIns="146304" rIns="201168" rtlCol="0" anchor="t"/>
           <a:lstStyle/>
           <a:p>
             <a:pPr algn="l" latinLnBrk="0">
@@ -8006,7 +8024,7 @@
           </a:fontRef>
         </p:style>
         <p:txBody>
-          <a:bodyPr rtlCol="0" anchor="t" wrap="square" lIns="201168" rIns="201168" tIns="146304"/>
+          <a:bodyPr wrap="square" lIns="201168" tIns="146304" rIns="201168" rtlCol="0" anchor="t"/>
           <a:lstStyle/>
           <a:p>
             <a:pPr algn="l" latinLnBrk="0">
@@ -8082,7 +8100,7 @@
           </a:fontRef>
         </p:style>
         <p:txBody>
-          <a:bodyPr rtlCol="0" anchor="t" wrap="square" lIns="201168" rIns="201168" tIns="146304"/>
+          <a:bodyPr wrap="square" lIns="201168" tIns="146304" rIns="201168" rtlCol="0" anchor="t"/>
           <a:lstStyle/>
           <a:p>
             <a:pPr algn="l" latinLnBrk="0">
@@ -8127,7 +8145,7 @@
 </file>
 
 <file path=ppt/slides/slide2.xml><?xml version="1.0" encoding="utf-8"?>
-<p:sld xmlns:a="http://schemas.openxmlformats.org/drawingml/2006/main" xmlns:p="http://schemas.openxmlformats.org/presentationml/2006/main" xmlns:r="http://schemas.openxmlformats.org/officeDocument/2006/relationships">
+<p:sld xmlns:a="http://schemas.openxmlformats.org/drawingml/2006/main" xmlns:r="http://schemas.openxmlformats.org/officeDocument/2006/relationships" xmlns:p="http://schemas.openxmlformats.org/presentationml/2006/main">
   <p:cSld>
     <p:bg>
       <p:bgPr>
@@ -8143,7 +8161,14 @@
         <p:cNvGrpSpPr/>
         <p:nvPr/>
       </p:nvGrpSpPr>
-      <p:grpSpPr/>
+      <p:grpSpPr>
+        <a:xfrm>
+          <a:off x="0" y="0"/>
+          <a:ext cx="0" cy="0"/>
+          <a:chOff x="0" y="0"/>
+          <a:chExt cx="0" cy="0"/>
+        </a:xfrm>
+      </p:grpSpPr>
       <p:sp>
         <p:nvSpPr>
           <p:cNvPr id="2" name="TextBox 1"/>
@@ -8161,7 +8186,7 @@
           <a:noFill/>
         </p:spPr>
         <p:txBody>
-          <a:bodyPr wrap="square" anchor="t" lIns="27432" rIns="27432" tIns="18288" bIns="18288">
+          <a:bodyPr wrap="square" lIns="27432" tIns="18288" rIns="27432" bIns="18288" anchor="t">
             <a:spAutoFit/>
           </a:bodyPr>
           <a:lstStyle/>
@@ -8200,7 +8225,7 @@
           <a:noFill/>
         </p:spPr>
         <p:txBody>
-          <a:bodyPr wrap="square" anchor="t" lIns="27432" rIns="27432" tIns="18288" bIns="18288">
+          <a:bodyPr wrap="square" lIns="27432" tIns="18288" rIns="27432" bIns="18288" anchor="t">
             <a:spAutoFit/>
           </a:bodyPr>
           <a:lstStyle/>
@@ -8239,7 +8264,7 @@
           <a:noFill/>
         </p:spPr>
         <p:txBody>
-          <a:bodyPr wrap="square" anchor="t" lIns="27432" rIns="27432" tIns="18288" bIns="18288">
+          <a:bodyPr wrap="square" lIns="27432" tIns="18288" rIns="27432" bIns="18288" anchor="t">
             <a:spAutoFit/>
           </a:bodyPr>
           <a:lstStyle/>
@@ -8278,7 +8303,7 @@
           <a:noFill/>
         </p:spPr>
         <p:txBody>
-          <a:bodyPr wrap="square" anchor="t" lIns="27432" rIns="27432" tIns="18288" bIns="18288">
+          <a:bodyPr wrap="square" lIns="27432" tIns="18288" rIns="27432" bIns="18288" anchor="t">
             <a:spAutoFit/>
           </a:bodyPr>
           <a:lstStyle/>
@@ -8317,7 +8342,7 @@
           <a:noFill/>
         </p:spPr>
         <p:txBody>
-          <a:bodyPr wrap="square" anchor="t" lIns="27432" rIns="27432" tIns="18288" bIns="18288">
+          <a:bodyPr wrap="square" lIns="27432" tIns="18288" rIns="27432" bIns="18288" anchor="t">
             <a:spAutoFit/>
           </a:bodyPr>
           <a:lstStyle/>
@@ -8379,7 +8404,7 @@
           </a:fontRef>
         </p:style>
         <p:txBody>
-          <a:bodyPr rtlCol="0" anchor="t" wrap="square" lIns="201168" rIns="201168" tIns="146304"/>
+          <a:bodyPr wrap="square" lIns="201168" tIns="146304" rIns="201168" rtlCol="0" anchor="t"/>
           <a:lstStyle/>
           <a:p>
             <a:pPr algn="l" latinLnBrk="0">
@@ -8455,7 +8480,7 @@
           </a:fontRef>
         </p:style>
         <p:txBody>
-          <a:bodyPr rtlCol="0" anchor="t" wrap="square" lIns="201168" rIns="201168" tIns="146304"/>
+          <a:bodyPr wrap="square" lIns="201168" tIns="146304" rIns="201168" rtlCol="0" anchor="t"/>
           <a:lstStyle/>
           <a:p>
             <a:pPr algn="l" latinLnBrk="0">
@@ -8531,7 +8556,7 @@
           </a:fontRef>
         </p:style>
         <p:txBody>
-          <a:bodyPr rtlCol="0" anchor="t" wrap="square" lIns="201168" rIns="201168" tIns="146304"/>
+          <a:bodyPr wrap="square" lIns="201168" tIns="146304" rIns="201168" rtlCol="0" anchor="t"/>
           <a:lstStyle/>
           <a:p>
             <a:pPr algn="l" latinLnBrk="0">
@@ -8575,7 +8600,7 @@
         </p:nvSpPr>
         <p:spPr>
           <a:xfrm>
-            <a:off x="502920" y="6144768"/>
+            <a:off x="502920" y="5986018"/>
             <a:ext cx="11185855" cy="475488"/>
           </a:xfrm>
           <a:prstGeom prst="roundRect">
@@ -8605,7 +8630,7 @@
           </a:fontRef>
         </p:style>
         <p:txBody>
-          <a:bodyPr rtlCol="0" anchor="ctr" wrap="square"/>
+          <a:bodyPr wrap="square" rtlCol="0" anchor="ctr"/>
           <a:lstStyle/>
           <a:p>
             <a:pPr algn="ctr" latinLnBrk="0"/>
@@ -8630,7 +8655,7 @@
 </file>
 
 <file path=ppt/slides/slide3.xml><?xml version="1.0" encoding="utf-8"?>
-<p:sld xmlns:a="http://schemas.openxmlformats.org/drawingml/2006/main" xmlns:p="http://schemas.openxmlformats.org/presentationml/2006/main" xmlns:r="http://schemas.openxmlformats.org/officeDocument/2006/relationships">
+<p:sld xmlns:a="http://schemas.openxmlformats.org/drawingml/2006/main" xmlns:r="http://schemas.openxmlformats.org/officeDocument/2006/relationships" xmlns:p="http://schemas.openxmlformats.org/presentationml/2006/main">
   <p:cSld>
     <p:bg>
       <p:bgPr>
@@ -8646,7 +8671,14 @@
         <p:cNvGrpSpPr/>
         <p:nvPr/>
       </p:nvGrpSpPr>
-      <p:grpSpPr/>
+      <p:grpSpPr>
+        <a:xfrm>
+          <a:off x="0" y="0"/>
+          <a:ext cx="0" cy="0"/>
+          <a:chOff x="0" y="0"/>
+          <a:chExt cx="0" cy="0"/>
+        </a:xfrm>
+      </p:grpSpPr>
       <p:sp>
         <p:nvSpPr>
           <p:cNvPr id="2" name="TextBox 1"/>
@@ -8664,7 +8696,7 @@
           <a:noFill/>
         </p:spPr>
         <p:txBody>
-          <a:bodyPr wrap="square" anchor="t" lIns="27432" rIns="27432" tIns="18288" bIns="18288">
+          <a:bodyPr wrap="square" lIns="27432" tIns="18288" rIns="27432" bIns="18288" anchor="t">
             <a:spAutoFit/>
           </a:bodyPr>
           <a:lstStyle/>
@@ -8703,7 +8735,7 @@
           <a:noFill/>
         </p:spPr>
         <p:txBody>
-          <a:bodyPr wrap="square" anchor="t" lIns="27432" rIns="27432" tIns="18288" bIns="18288">
+          <a:bodyPr wrap="square" lIns="27432" tIns="18288" rIns="27432" bIns="18288" anchor="t">
             <a:spAutoFit/>
           </a:bodyPr>
           <a:lstStyle/>
@@ -8742,7 +8774,7 @@
           <a:noFill/>
         </p:spPr>
         <p:txBody>
-          <a:bodyPr wrap="square" anchor="t" lIns="27432" rIns="27432" tIns="18288" bIns="18288">
+          <a:bodyPr wrap="square" lIns="27432" tIns="18288" rIns="27432" bIns="18288" anchor="t">
             <a:spAutoFit/>
           </a:bodyPr>
           <a:lstStyle/>
@@ -8781,7 +8813,7 @@
           <a:noFill/>
         </p:spPr>
         <p:txBody>
-          <a:bodyPr wrap="square" anchor="t" lIns="27432" rIns="27432" tIns="18288" bIns="18288">
+          <a:bodyPr wrap="square" lIns="27432" tIns="18288" rIns="27432" bIns="18288" anchor="t">
             <a:spAutoFit/>
           </a:bodyPr>
           <a:lstStyle/>
@@ -8843,7 +8875,7 @@
           </a:fontRef>
         </p:style>
         <p:txBody>
-          <a:bodyPr rtlCol="0" anchor="t" wrap="square" lIns="201168" rIns="201168" tIns="146304"/>
+          <a:bodyPr wrap="square" lIns="201168" tIns="146304" rIns="201168" rtlCol="0" anchor="t"/>
           <a:lstStyle/>
           <a:p>
             <a:pPr algn="l" latinLnBrk="0">
@@ -8919,7 +8951,7 @@
           </a:fontRef>
         </p:style>
         <p:txBody>
-          <a:bodyPr rtlCol="0" anchor="t" wrap="square" lIns="201168" rIns="201168" tIns="146304"/>
+          <a:bodyPr wrap="square" lIns="201168" tIns="146304" rIns="201168" rtlCol="0" anchor="t"/>
           <a:lstStyle/>
           <a:p>
             <a:pPr algn="l" latinLnBrk="0">
@@ -8995,7 +9027,7 @@
           </a:fontRef>
         </p:style>
         <p:txBody>
-          <a:bodyPr rtlCol="0" anchor="t" wrap="square" lIns="201168" rIns="201168" tIns="146304"/>
+          <a:bodyPr wrap="square" lIns="201168" tIns="146304" rIns="201168" rtlCol="0" anchor="t"/>
           <a:lstStyle/>
           <a:p>
             <a:pPr algn="l" latinLnBrk="0">
@@ -9071,7 +9103,7 @@
           </a:fontRef>
         </p:style>
         <p:txBody>
-          <a:bodyPr rtlCol="0" anchor="t" wrap="square" lIns="201168" rIns="201168" tIns="146304"/>
+          <a:bodyPr wrap="square" lIns="201168" tIns="146304" rIns="201168" rtlCol="0" anchor="t"/>
           <a:lstStyle/>
           <a:p>
             <a:pPr algn="l" latinLnBrk="0">
@@ -9116,7 +9148,7 @@
 </file>
 
 <file path=ppt/slides/slide4.xml><?xml version="1.0" encoding="utf-8"?>
-<p:sld xmlns:a="http://schemas.openxmlformats.org/drawingml/2006/main" xmlns:p="http://schemas.openxmlformats.org/presentationml/2006/main" xmlns:r="http://schemas.openxmlformats.org/officeDocument/2006/relationships">
+<p:sld xmlns:a="http://schemas.openxmlformats.org/drawingml/2006/main" xmlns:r="http://schemas.openxmlformats.org/officeDocument/2006/relationships" xmlns:p="http://schemas.openxmlformats.org/presentationml/2006/main">
   <p:cSld>
     <p:bg>
       <p:bgPr>
@@ -9132,7 +9164,14 @@
         <p:cNvGrpSpPr/>
         <p:nvPr/>
       </p:nvGrpSpPr>
-      <p:grpSpPr/>
+      <p:grpSpPr>
+        <a:xfrm>
+          <a:off x="0" y="0"/>
+          <a:ext cx="0" cy="0"/>
+          <a:chOff x="0" y="0"/>
+          <a:chExt cx="0" cy="0"/>
+        </a:xfrm>
+      </p:grpSpPr>
       <p:sp>
         <p:nvSpPr>
           <p:cNvPr id="2" name="TextBox 1"/>
@@ -9150,7 +9189,7 @@
           <a:noFill/>
         </p:spPr>
         <p:txBody>
-          <a:bodyPr wrap="square" anchor="t" lIns="27432" rIns="27432" tIns="18288" bIns="18288">
+          <a:bodyPr wrap="square" lIns="27432" tIns="18288" rIns="27432" bIns="18288" anchor="t">
             <a:spAutoFit/>
           </a:bodyPr>
           <a:lstStyle/>
@@ -9189,7 +9228,7 @@
           <a:noFill/>
         </p:spPr>
         <p:txBody>
-          <a:bodyPr wrap="square" anchor="t" lIns="27432" rIns="27432" tIns="18288" bIns="18288">
+          <a:bodyPr wrap="square" lIns="27432" tIns="18288" rIns="27432" bIns="18288" anchor="t">
             <a:spAutoFit/>
           </a:bodyPr>
           <a:lstStyle/>
@@ -9228,7 +9267,7 @@
           <a:noFill/>
         </p:spPr>
         <p:txBody>
-          <a:bodyPr wrap="square" anchor="t" lIns="27432" rIns="27432" tIns="18288" bIns="18288">
+          <a:bodyPr wrap="square" lIns="27432" tIns="18288" rIns="27432" bIns="18288" anchor="t">
             <a:spAutoFit/>
           </a:bodyPr>
           <a:lstStyle/>
@@ -9267,7 +9306,7 @@
           <a:noFill/>
         </p:spPr>
         <p:txBody>
-          <a:bodyPr wrap="square" anchor="t" lIns="27432" rIns="27432" tIns="18288" bIns="18288">
+          <a:bodyPr wrap="square" lIns="27432" tIns="18288" rIns="27432" bIns="18288" anchor="t">
             <a:spAutoFit/>
           </a:bodyPr>
           <a:lstStyle/>
@@ -9321,7 +9360,7 @@
         </p:nvSpPr>
         <p:spPr>
           <a:xfrm>
-            <a:off x="502920" y="6144768"/>
+            <a:off x="502920" y="5922518"/>
             <a:ext cx="11185855" cy="475488"/>
           </a:xfrm>
           <a:prstGeom prst="roundRect">
@@ -9351,7 +9390,7 @@
           </a:fontRef>
         </p:style>
         <p:txBody>
-          <a:bodyPr rtlCol="0" anchor="ctr" wrap="square"/>
+          <a:bodyPr wrap="square" rtlCol="0" anchor="ctr"/>
           <a:lstStyle/>
           <a:p>
             <a:pPr algn="ctr" latinLnBrk="0"/>
@@ -9376,7 +9415,7 @@
 </file>
 
 <file path=ppt/slides/slide5.xml><?xml version="1.0" encoding="utf-8"?>
-<p:sld xmlns:a="http://schemas.openxmlformats.org/drawingml/2006/main" xmlns:p="http://schemas.openxmlformats.org/presentationml/2006/main" xmlns:r="http://schemas.openxmlformats.org/officeDocument/2006/relationships">
+<p:sld xmlns:a="http://schemas.openxmlformats.org/drawingml/2006/main" xmlns:r="http://schemas.openxmlformats.org/officeDocument/2006/relationships" xmlns:p="http://schemas.openxmlformats.org/presentationml/2006/main">
   <p:cSld>
     <p:bg>
       <p:bgPr>
@@ -9392,7 +9431,14 @@
         <p:cNvGrpSpPr/>
         <p:nvPr/>
       </p:nvGrpSpPr>
-      <p:grpSpPr/>
+      <p:grpSpPr>
+        <a:xfrm>
+          <a:off x="0" y="0"/>
+          <a:ext cx="0" cy="0"/>
+          <a:chOff x="0" y="0"/>
+          <a:chExt cx="0" cy="0"/>
+        </a:xfrm>
+      </p:grpSpPr>
       <p:sp>
         <p:nvSpPr>
           <p:cNvPr id="2" name="TextBox 1"/>
@@ -9410,7 +9456,7 @@
           <a:noFill/>
         </p:spPr>
         <p:txBody>
-          <a:bodyPr wrap="square" anchor="t" lIns="27432" rIns="27432" tIns="18288" bIns="18288">
+          <a:bodyPr wrap="square" lIns="27432" tIns="18288" rIns="27432" bIns="18288" anchor="t">
             <a:spAutoFit/>
           </a:bodyPr>
           <a:lstStyle/>
@@ -9449,7 +9495,7 @@
           <a:noFill/>
         </p:spPr>
         <p:txBody>
-          <a:bodyPr wrap="square" anchor="t" lIns="27432" rIns="27432" tIns="18288" bIns="18288">
+          <a:bodyPr wrap="square" lIns="27432" tIns="18288" rIns="27432" bIns="18288" anchor="t">
             <a:spAutoFit/>
           </a:bodyPr>
           <a:lstStyle/>
@@ -9488,7 +9534,7 @@
           <a:noFill/>
         </p:spPr>
         <p:txBody>
-          <a:bodyPr wrap="square" anchor="t" lIns="27432" rIns="27432" tIns="18288" bIns="18288">
+          <a:bodyPr wrap="square" lIns="27432" tIns="18288" rIns="27432" bIns="18288" anchor="t">
             <a:spAutoFit/>
           </a:bodyPr>
           <a:lstStyle/>
@@ -9527,7 +9573,7 @@
           <a:noFill/>
         </p:spPr>
         <p:txBody>
-          <a:bodyPr wrap="square" anchor="t" lIns="27432" rIns="27432" tIns="18288" bIns="18288">
+          <a:bodyPr wrap="square" lIns="27432" tIns="18288" rIns="27432" bIns="18288" anchor="t">
             <a:spAutoFit/>
           </a:bodyPr>
           <a:lstStyle/>
@@ -9589,7 +9635,7 @@
           </a:fontRef>
         </p:style>
         <p:txBody>
-          <a:bodyPr rtlCol="0" anchor="t" wrap="square" lIns="201168" rIns="201168" tIns="146304"/>
+          <a:bodyPr wrap="square" lIns="201168" tIns="146304" rIns="201168" rtlCol="0" anchor="t"/>
           <a:lstStyle/>
           <a:p>
             <a:pPr algn="l" latinLnBrk="0">
@@ -9665,7 +9711,7 @@
           </a:fontRef>
         </p:style>
         <p:txBody>
-          <a:bodyPr rtlCol="0" anchor="t" wrap="square" lIns="201168" rIns="201168" tIns="146304"/>
+          <a:bodyPr wrap="square" lIns="201168" tIns="146304" rIns="201168" rtlCol="0" anchor="t"/>
           <a:lstStyle/>
           <a:p>
             <a:pPr algn="l" latinLnBrk="0">
@@ -9741,7 +9787,7 @@
           </a:fontRef>
         </p:style>
         <p:txBody>
-          <a:bodyPr rtlCol="0" anchor="t" wrap="square" lIns="201168" rIns="201168" tIns="146304"/>
+          <a:bodyPr wrap="square" lIns="201168" tIns="146304" rIns="201168" rtlCol="0" anchor="t"/>
           <a:lstStyle/>
           <a:p>
             <a:pPr algn="l" latinLnBrk="0">
@@ -9794,7 +9840,7 @@
           <a:noFill/>
         </p:spPr>
         <p:txBody>
-          <a:bodyPr wrap="square" anchor="t" lIns="27432" rIns="27432" tIns="18288" bIns="18288">
+          <a:bodyPr wrap="square" lIns="27432" tIns="18288" rIns="27432" bIns="18288" anchor="t">
             <a:spAutoFit/>
           </a:bodyPr>
           <a:lstStyle/>
@@ -9824,7 +9870,7 @@
         </p:nvSpPr>
         <p:spPr>
           <a:xfrm>
-            <a:off x="502920" y="6144768"/>
+            <a:off x="502920" y="5992368"/>
             <a:ext cx="11185855" cy="475488"/>
           </a:xfrm>
           <a:prstGeom prst="roundRect">
@@ -9854,7 +9900,7 @@
           </a:fontRef>
         </p:style>
         <p:txBody>
-          <a:bodyPr rtlCol="0" anchor="ctr" wrap="square"/>
+          <a:bodyPr wrap="square" rtlCol="0" anchor="ctr"/>
           <a:lstStyle/>
           <a:p>
             <a:pPr algn="ctr" latinLnBrk="0"/>
@@ -9879,7 +9925,7 @@
 </file>
 
 <file path=ppt/slides/slide6.xml><?xml version="1.0" encoding="utf-8"?>
-<p:sld xmlns:a="http://schemas.openxmlformats.org/drawingml/2006/main" xmlns:p="http://schemas.openxmlformats.org/presentationml/2006/main" xmlns:r="http://schemas.openxmlformats.org/officeDocument/2006/relationships">
+<p:sld xmlns:a="http://schemas.openxmlformats.org/drawingml/2006/main" xmlns:r="http://schemas.openxmlformats.org/officeDocument/2006/relationships" xmlns:p="http://schemas.openxmlformats.org/presentationml/2006/main">
   <p:cSld>
     <p:bg>
       <p:bgPr>
@@ -9895,7 +9941,14 @@
         <p:cNvGrpSpPr/>
         <p:nvPr/>
       </p:nvGrpSpPr>
-      <p:grpSpPr/>
+      <p:grpSpPr>
+        <a:xfrm>
+          <a:off x="0" y="0"/>
+          <a:ext cx="0" cy="0"/>
+          <a:chOff x="0" y="0"/>
+          <a:chExt cx="0" cy="0"/>
+        </a:xfrm>
+      </p:grpSpPr>
       <p:sp>
         <p:nvSpPr>
           <p:cNvPr id="2" name="TextBox 1"/>
@@ -9913,7 +9966,7 @@
           <a:noFill/>
         </p:spPr>
         <p:txBody>
-          <a:bodyPr wrap="square" anchor="t" lIns="27432" rIns="27432" tIns="18288" bIns="18288">
+          <a:bodyPr wrap="square" lIns="27432" tIns="18288" rIns="27432" bIns="18288" anchor="t">
             <a:spAutoFit/>
           </a:bodyPr>
           <a:lstStyle/>
@@ -9952,7 +10005,7 @@
           <a:noFill/>
         </p:spPr>
         <p:txBody>
-          <a:bodyPr wrap="square" anchor="t" lIns="27432" rIns="27432" tIns="18288" bIns="18288">
+          <a:bodyPr wrap="square" lIns="27432" tIns="18288" rIns="27432" bIns="18288" anchor="t">
             <a:spAutoFit/>
           </a:bodyPr>
           <a:lstStyle/>
@@ -9991,7 +10044,7 @@
           <a:noFill/>
         </p:spPr>
         <p:txBody>
-          <a:bodyPr wrap="square" anchor="t" lIns="27432" rIns="27432" tIns="18288" bIns="18288">
+          <a:bodyPr wrap="square" lIns="27432" tIns="18288" rIns="27432" bIns="18288" anchor="t">
             <a:spAutoFit/>
           </a:bodyPr>
           <a:lstStyle/>
@@ -10030,7 +10083,7 @@
           <a:noFill/>
         </p:spPr>
         <p:txBody>
-          <a:bodyPr wrap="square" anchor="t" lIns="27432" rIns="27432" tIns="18288" bIns="18288">
+          <a:bodyPr wrap="square" lIns="27432" tIns="18288" rIns="27432" bIns="18288" anchor="t">
             <a:spAutoFit/>
           </a:bodyPr>
           <a:lstStyle/>
@@ -10069,7 +10122,7 @@
           <a:noFill/>
         </p:spPr>
         <p:txBody>
-          <a:bodyPr wrap="square" anchor="t" lIns="27432" rIns="27432" tIns="18288" bIns="18288">
+          <a:bodyPr wrap="square" lIns="27432" tIns="18288" rIns="27432" bIns="18288" anchor="t">
             <a:spAutoFit/>
           </a:bodyPr>
           <a:lstStyle/>
@@ -10131,7 +10184,7 @@
           </a:fontRef>
         </p:style>
         <p:txBody>
-          <a:bodyPr rtlCol="0" anchor="ctr" wrap="square"/>
+          <a:bodyPr wrap="square" rtlCol="0" anchor="ctr"/>
           <a:lstStyle/>
           <a:p>
             <a:pPr algn="ctr" latinLnBrk="0"/>
@@ -10199,7 +10252,7 @@
           </a:fontRef>
         </p:style>
         <p:txBody>
-          <a:bodyPr rtlCol="0" anchor="ctr" wrap="square"/>
+          <a:bodyPr wrap="square" rtlCol="0" anchor="ctr"/>
           <a:lstStyle/>
           <a:p>
             <a:pPr algn="ctr" latinLnBrk="0"/>
@@ -10267,7 +10320,7 @@
           </a:fontRef>
         </p:style>
         <p:txBody>
-          <a:bodyPr rtlCol="0" anchor="ctr" wrap="square"/>
+          <a:bodyPr wrap="square" rtlCol="0" anchor="ctr"/>
           <a:lstStyle/>
           <a:p>
             <a:pPr algn="ctr" latinLnBrk="0"/>
@@ -10335,7 +10388,7 @@
           </a:fontRef>
         </p:style>
         <p:txBody>
-          <a:bodyPr rtlCol="0" anchor="ctr" wrap="square"/>
+          <a:bodyPr wrap="square" rtlCol="0" anchor="ctr"/>
           <a:lstStyle/>
           <a:p>
             <a:pPr algn="ctr" latinLnBrk="0"/>
@@ -10403,7 +10456,7 @@
           </a:fontRef>
         </p:style>
         <p:txBody>
-          <a:bodyPr rtlCol="0" anchor="ctr" wrap="square"/>
+          <a:bodyPr wrap="square" rtlCol="0" anchor="ctr"/>
           <a:lstStyle/>
           <a:p>
             <a:pPr algn="ctr" latinLnBrk="0"/>
@@ -10448,7 +10501,7 @@
           <a:noFill/>
         </p:spPr>
         <p:txBody>
-          <a:bodyPr wrap="square" anchor="t" lIns="27432" rIns="27432" tIns="18288" bIns="18288">
+          <a:bodyPr wrap="square" lIns="27432" tIns="18288" rIns="27432" bIns="18288" anchor="t">
             <a:spAutoFit/>
           </a:bodyPr>
           <a:lstStyle/>
@@ -10510,7 +10563,7 @@
           </a:fontRef>
         </p:style>
         <p:txBody>
-          <a:bodyPr rtlCol="0" anchor="t" wrap="square" lIns="201168" rIns="201168" tIns="146304"/>
+          <a:bodyPr wrap="square" lIns="201168" tIns="146304" rIns="201168" rtlCol="0" anchor="t"/>
           <a:lstStyle/>
           <a:p>
             <a:pPr algn="l" latinLnBrk="0">
@@ -10554,7 +10607,7 @@
         </p:nvSpPr>
         <p:spPr>
           <a:xfrm>
-            <a:off x="502920" y="6144768"/>
+            <a:off x="502920" y="5992368"/>
             <a:ext cx="11185855" cy="475488"/>
           </a:xfrm>
           <a:prstGeom prst="roundRect">
@@ -10584,7 +10637,7 @@
           </a:fontRef>
         </p:style>
         <p:txBody>
-          <a:bodyPr rtlCol="0" anchor="ctr" wrap="square"/>
+          <a:bodyPr wrap="square" rtlCol="0" anchor="ctr"/>
           <a:lstStyle/>
           <a:p>
             <a:pPr algn="ctr" latinLnBrk="0"/>
@@ -10609,7 +10662,7 @@
 </file>
 
 <file path=ppt/slides/slide7.xml><?xml version="1.0" encoding="utf-8"?>
-<p:sld xmlns:a="http://schemas.openxmlformats.org/drawingml/2006/main" xmlns:p="http://schemas.openxmlformats.org/presentationml/2006/main" xmlns:r="http://schemas.openxmlformats.org/officeDocument/2006/relationships">
+<p:sld xmlns:a="http://schemas.openxmlformats.org/drawingml/2006/main" xmlns:r="http://schemas.openxmlformats.org/officeDocument/2006/relationships" xmlns:p="http://schemas.openxmlformats.org/presentationml/2006/main">
   <p:cSld>
     <p:bg>
       <p:bgPr>
@@ -10625,7 +10678,14 @@
         <p:cNvGrpSpPr/>
         <p:nvPr/>
       </p:nvGrpSpPr>
-      <p:grpSpPr/>
+      <p:grpSpPr>
+        <a:xfrm>
+          <a:off x="0" y="0"/>
+          <a:ext cx="0" cy="0"/>
+          <a:chOff x="0" y="0"/>
+          <a:chExt cx="0" cy="0"/>
+        </a:xfrm>
+      </p:grpSpPr>
       <p:sp>
         <p:nvSpPr>
           <p:cNvPr id="2" name="TextBox 1"/>
@@ -10643,7 +10703,7 @@
           <a:noFill/>
         </p:spPr>
         <p:txBody>
-          <a:bodyPr wrap="square" anchor="t" lIns="27432" rIns="27432" tIns="18288" bIns="18288">
+          <a:bodyPr wrap="square" lIns="27432" tIns="18288" rIns="27432" bIns="18288" anchor="t">
             <a:spAutoFit/>
           </a:bodyPr>
           <a:lstStyle/>
@@ -10682,7 +10742,7 @@
           <a:noFill/>
         </p:spPr>
         <p:txBody>
-          <a:bodyPr wrap="square" anchor="t" lIns="27432" rIns="27432" tIns="18288" bIns="18288">
+          <a:bodyPr wrap="square" lIns="27432" tIns="18288" rIns="27432" bIns="18288" anchor="t">
             <a:spAutoFit/>
           </a:bodyPr>
           <a:lstStyle/>
@@ -10721,7 +10781,7 @@
           <a:noFill/>
         </p:spPr>
         <p:txBody>
-          <a:bodyPr wrap="square" anchor="t" lIns="27432" rIns="27432" tIns="18288" bIns="18288">
+          <a:bodyPr wrap="square" lIns="27432" tIns="18288" rIns="27432" bIns="18288" anchor="t">
             <a:spAutoFit/>
           </a:bodyPr>
           <a:lstStyle/>
@@ -10760,7 +10820,7 @@
           <a:noFill/>
         </p:spPr>
         <p:txBody>
-          <a:bodyPr wrap="square" anchor="t" lIns="27432" rIns="27432" tIns="18288" bIns="18288">
+          <a:bodyPr wrap="square" lIns="27432" tIns="18288" rIns="27432" bIns="18288" anchor="t">
             <a:spAutoFit/>
           </a:bodyPr>
           <a:lstStyle/>
@@ -10822,7 +10882,7 @@
           </a:fontRef>
         </p:style>
         <p:txBody>
-          <a:bodyPr rtlCol="0" anchor="t" wrap="square" lIns="201168" rIns="201168" tIns="146304"/>
+          <a:bodyPr wrap="square" lIns="201168" tIns="146304" rIns="201168" rtlCol="0" anchor="t"/>
           <a:lstStyle/>
           <a:p>
             <a:pPr algn="l" latinLnBrk="0">
@@ -10898,7 +10958,7 @@
           </a:fontRef>
         </p:style>
         <p:txBody>
-          <a:bodyPr rtlCol="0" anchor="t" wrap="square" lIns="201168" rIns="201168" tIns="146304"/>
+          <a:bodyPr wrap="square" lIns="201168" tIns="146304" rIns="201168" rtlCol="0" anchor="t"/>
           <a:lstStyle/>
           <a:p>
             <a:pPr algn="l" latinLnBrk="0">
@@ -10974,7 +11034,7 @@
           </a:fontRef>
         </p:style>
         <p:txBody>
-          <a:bodyPr rtlCol="0" anchor="t" wrap="square" lIns="201168" rIns="201168" tIns="146304"/>
+          <a:bodyPr wrap="square" lIns="201168" tIns="146304" rIns="201168" rtlCol="0" anchor="t"/>
           <a:lstStyle/>
           <a:p>
             <a:pPr algn="l" latinLnBrk="0">
@@ -11050,7 +11110,7 @@
           </a:fontRef>
         </p:style>
         <p:txBody>
-          <a:bodyPr rtlCol="0" anchor="t" wrap="square" lIns="201168" rIns="201168" tIns="146304"/>
+          <a:bodyPr wrap="square" lIns="201168" tIns="146304" rIns="201168" rtlCol="0" anchor="t"/>
           <a:lstStyle/>
           <a:p>
             <a:pPr algn="l" latinLnBrk="0">
@@ -11095,7 +11155,7 @@
 </file>
 
 <file path=ppt/slides/slide8.xml><?xml version="1.0" encoding="utf-8"?>
-<p:sld xmlns:a="http://schemas.openxmlformats.org/drawingml/2006/main" xmlns:p="http://schemas.openxmlformats.org/presentationml/2006/main" xmlns:r="http://schemas.openxmlformats.org/officeDocument/2006/relationships">
+<p:sld xmlns:a="http://schemas.openxmlformats.org/drawingml/2006/main" xmlns:r="http://schemas.openxmlformats.org/officeDocument/2006/relationships" xmlns:p="http://schemas.openxmlformats.org/presentationml/2006/main">
   <p:cSld>
     <p:bg>
       <p:bgPr>
@@ -11111,7 +11171,14 @@
         <p:cNvGrpSpPr/>
         <p:nvPr/>
       </p:nvGrpSpPr>
-      <p:grpSpPr/>
+      <p:grpSpPr>
+        <a:xfrm>
+          <a:off x="0" y="0"/>
+          <a:ext cx="0" cy="0"/>
+          <a:chOff x="0" y="0"/>
+          <a:chExt cx="0" cy="0"/>
+        </a:xfrm>
+      </p:grpSpPr>
       <p:sp>
         <p:nvSpPr>
           <p:cNvPr id="2" name="TextBox 1"/>
@@ -11129,7 +11196,7 @@
           <a:noFill/>
         </p:spPr>
         <p:txBody>
-          <a:bodyPr wrap="square" anchor="t" lIns="27432" rIns="27432" tIns="18288" bIns="18288">
+          <a:bodyPr wrap="square" lIns="27432" tIns="18288" rIns="27432" bIns="18288" anchor="t">
             <a:spAutoFit/>
           </a:bodyPr>
           <a:lstStyle/>
@@ -11168,7 +11235,7 @@
           <a:noFill/>
         </p:spPr>
         <p:txBody>
-          <a:bodyPr wrap="square" anchor="t" lIns="27432" rIns="27432" tIns="18288" bIns="18288">
+          <a:bodyPr wrap="square" lIns="27432" tIns="18288" rIns="27432" bIns="18288" anchor="t">
             <a:spAutoFit/>
           </a:bodyPr>
           <a:lstStyle/>
@@ -11207,7 +11274,7 @@
           <a:noFill/>
         </p:spPr>
         <p:txBody>
-          <a:bodyPr wrap="square" anchor="t" lIns="27432" rIns="27432" tIns="18288" bIns="18288">
+          <a:bodyPr wrap="square" lIns="27432" tIns="18288" rIns="27432" bIns="18288" anchor="t">
             <a:spAutoFit/>
           </a:bodyPr>
           <a:lstStyle/>
@@ -11246,7 +11313,7 @@
           <a:noFill/>
         </p:spPr>
         <p:txBody>
-          <a:bodyPr wrap="square" anchor="t" lIns="27432" rIns="27432" tIns="18288" bIns="18288">
+          <a:bodyPr wrap="square" lIns="27432" tIns="18288" rIns="27432" bIns="18288" anchor="t">
             <a:spAutoFit/>
           </a:bodyPr>
           <a:lstStyle/>
@@ -11308,7 +11375,7 @@
           </a:fontRef>
         </p:style>
         <p:txBody>
-          <a:bodyPr rtlCol="0" anchor="t" wrap="square" lIns="201168" rIns="201168" tIns="146304"/>
+          <a:bodyPr wrap="square" lIns="201168" tIns="146304" rIns="201168" rtlCol="0" anchor="t"/>
           <a:lstStyle/>
           <a:p>
             <a:pPr algn="l" latinLnBrk="0">
@@ -11384,7 +11451,7 @@
           </a:fontRef>
         </p:style>
         <p:txBody>
-          <a:bodyPr rtlCol="0" anchor="t" wrap="square" lIns="201168" rIns="201168" tIns="146304"/>
+          <a:bodyPr wrap="square" lIns="201168" tIns="146304" rIns="201168" rtlCol="0" anchor="t"/>
           <a:lstStyle/>
           <a:p>
             <a:pPr algn="l" latinLnBrk="0">
@@ -11460,7 +11527,7 @@
           </a:fontRef>
         </p:style>
         <p:txBody>
-          <a:bodyPr rtlCol="0" anchor="t" wrap="square" lIns="201168" rIns="201168" tIns="146304"/>
+          <a:bodyPr wrap="square" lIns="201168" tIns="146304" rIns="201168" rtlCol="0" anchor="t"/>
           <a:lstStyle/>
           <a:p>
             <a:pPr algn="l" latinLnBrk="0">
@@ -11536,7 +11603,7 @@
           </a:fontRef>
         </p:style>
         <p:txBody>
-          <a:bodyPr rtlCol="0" anchor="t" wrap="square" lIns="201168" rIns="201168" tIns="146304"/>
+          <a:bodyPr wrap="square" lIns="201168" tIns="146304" rIns="201168" rtlCol="0" anchor="t"/>
           <a:lstStyle/>
           <a:p>
             <a:pPr algn="l" latinLnBrk="0">
@@ -11580,7 +11647,7 @@
         </p:nvSpPr>
         <p:spPr>
           <a:xfrm>
-            <a:off x="502920" y="6144768"/>
+            <a:off x="502920" y="5941568"/>
             <a:ext cx="11185855" cy="475488"/>
           </a:xfrm>
           <a:prstGeom prst="roundRect">
@@ -11610,7 +11677,7 @@
           </a:fontRef>
         </p:style>
         <p:txBody>
-          <a:bodyPr rtlCol="0" anchor="ctr" wrap="square"/>
+          <a:bodyPr wrap="square" rtlCol="0" anchor="ctr"/>
           <a:lstStyle/>
           <a:p>
             <a:pPr algn="ctr" latinLnBrk="0"/>
@@ -11635,7 +11702,7 @@
 </file>
 
 <file path=ppt/slides/slide9.xml><?xml version="1.0" encoding="utf-8"?>
-<p:sld xmlns:a="http://schemas.openxmlformats.org/drawingml/2006/main" xmlns:p="http://schemas.openxmlformats.org/presentationml/2006/main" xmlns:r="http://schemas.openxmlformats.org/officeDocument/2006/relationships">
+<p:sld xmlns:a="http://schemas.openxmlformats.org/drawingml/2006/main" xmlns:r="http://schemas.openxmlformats.org/officeDocument/2006/relationships" xmlns:p="http://schemas.openxmlformats.org/presentationml/2006/main">
   <p:cSld>
     <p:bg>
       <p:bgPr>
@@ -11651,7 +11718,14 @@
         <p:cNvGrpSpPr/>
         <p:nvPr/>
       </p:nvGrpSpPr>
-      <p:grpSpPr/>
+      <p:grpSpPr>
+        <a:xfrm>
+          <a:off x="0" y="0"/>
+          <a:ext cx="0" cy="0"/>
+          <a:chOff x="0" y="0"/>
+          <a:chExt cx="0" cy="0"/>
+        </a:xfrm>
+      </p:grpSpPr>
       <p:sp>
         <p:nvSpPr>
           <p:cNvPr id="2" name="TextBox 1"/>
@@ -11669,7 +11743,7 @@
           <a:noFill/>
         </p:spPr>
         <p:txBody>
-          <a:bodyPr wrap="square" anchor="t" lIns="27432" rIns="27432" tIns="18288" bIns="18288">
+          <a:bodyPr wrap="square" lIns="27432" tIns="18288" rIns="27432" bIns="18288" anchor="t">
             <a:spAutoFit/>
           </a:bodyPr>
           <a:lstStyle/>
@@ -11708,7 +11782,7 @@
           <a:noFill/>
         </p:spPr>
         <p:txBody>
-          <a:bodyPr wrap="square" anchor="t" lIns="27432" rIns="27432" tIns="18288" bIns="18288">
+          <a:bodyPr wrap="square" lIns="27432" tIns="18288" rIns="27432" bIns="18288" anchor="t">
             <a:spAutoFit/>
           </a:bodyPr>
           <a:lstStyle/>
@@ -11747,7 +11821,7 @@
           <a:noFill/>
         </p:spPr>
         <p:txBody>
-          <a:bodyPr wrap="square" anchor="t" lIns="27432" rIns="27432" tIns="18288" bIns="18288">
+          <a:bodyPr wrap="square" lIns="27432" tIns="18288" rIns="27432" bIns="18288" anchor="t">
             <a:spAutoFit/>
           </a:bodyPr>
           <a:lstStyle/>
@@ -11786,7 +11860,7 @@
           <a:noFill/>
         </p:spPr>
         <p:txBody>
-          <a:bodyPr wrap="square" anchor="t" lIns="27432" rIns="27432" tIns="18288" bIns="18288">
+          <a:bodyPr wrap="square" lIns="27432" tIns="18288" rIns="27432" bIns="18288" anchor="t">
             <a:spAutoFit/>
           </a:bodyPr>
           <a:lstStyle/>
@@ -11848,7 +11922,7 @@
           </a:fontRef>
         </p:style>
         <p:txBody>
-          <a:bodyPr rtlCol="0" anchor="ctr" wrap="square"/>
+          <a:bodyPr wrap="square" rtlCol="0" anchor="ctr"/>
           <a:lstStyle/>
           <a:p>
             <a:pPr algn="ctr" latinLnBrk="0"/>
@@ -11916,7 +11990,7 @@
           </a:fontRef>
         </p:style>
         <p:txBody>
-          <a:bodyPr rtlCol="0" anchor="ctr" wrap="square"/>
+          <a:bodyPr wrap="square" rtlCol="0" anchor="ctr"/>
           <a:lstStyle/>
           <a:p>
             <a:pPr algn="ctr" latinLnBrk="0"/>
@@ -11984,7 +12058,7 @@
           </a:fontRef>
         </p:style>
         <p:txBody>
-          <a:bodyPr rtlCol="0" anchor="ctr" wrap="square"/>
+          <a:bodyPr wrap="square" rtlCol="0" anchor="ctr"/>
           <a:lstStyle/>
           <a:p>
             <a:pPr algn="ctr" latinLnBrk="0"/>
@@ -12052,7 +12126,7 @@
           </a:fontRef>
         </p:style>
         <p:txBody>
-          <a:bodyPr rtlCol="0" anchor="ctr" wrap="square"/>
+          <a:bodyPr wrap="square" rtlCol="0" anchor="ctr"/>
           <a:lstStyle/>
           <a:p>
             <a:pPr algn="ctr" latinLnBrk="0"/>
@@ -12144,7 +12218,7 @@
           </a:fontRef>
         </p:style>
         <p:txBody>
-          <a:bodyPr rtlCol="0" anchor="t" wrap="square" lIns="201168" rIns="201168" tIns="146304"/>
+          <a:bodyPr wrap="square" lIns="201168" tIns="146304" rIns="201168" rtlCol="0" anchor="t"/>
           <a:lstStyle/>
           <a:p>
             <a:pPr algn="l" latinLnBrk="0">
@@ -12188,7 +12262,7 @@
         </p:nvSpPr>
         <p:spPr>
           <a:xfrm>
-            <a:off x="502920" y="6144768"/>
+            <a:off x="502920" y="5966968"/>
             <a:ext cx="11185855" cy="475488"/>
           </a:xfrm>
           <a:prstGeom prst="roundRect">
@@ -12218,7 +12292,7 @@
           </a:fontRef>
         </p:style>
         <p:txBody>
-          <a:bodyPr rtlCol="0" anchor="ctr" wrap="square"/>
+          <a:bodyPr wrap="square" rtlCol="0" anchor="ctr"/>
           <a:lstStyle/>
           <a:p>
             <a:pPr algn="ctr" latinLnBrk="0"/>

</xml_diff>